<commit_message>
Update presentation deck with visual layouts and flowchart diagrams
</commit_message>
<xml_diff>
--- a/purplle_store_intelligence_deck.pptx
+++ b/purplle_store_intelligence_deck.pptx
@@ -3103,14 +3103,145 @@
       <p:grpSpPr/>
       <p:sp>
         <p:nvSpPr>
-          <p:cNvPr id="2" name="TextBox 1"/>
+          <p:cNvPr id="2" name="Oval 1"/>
+          <p:cNvSpPr/>
+          <p:nvPr/>
+        </p:nvSpPr>
+        <p:spPr>
+          <a:xfrm>
+            <a:off x="-1371600" y="-1371600"/>
+            <a:ext cx="4572000" cy="4572000"/>
+          </a:xfrm>
+          <a:prstGeom prst="ellipse">
+            <a:avLst/>
+          </a:prstGeom>
+          <a:solidFill>
+            <a:srgbClr val="7E22CE"/>
+          </a:solidFill>
+          <a:ln>
+            <a:noFill/>
+          </a:ln>
+        </p:spPr>
+        <p:style>
+          <a:lnRef idx="1">
+            <a:schemeClr val="accent1"/>
+          </a:lnRef>
+          <a:fillRef idx="3">
+            <a:schemeClr val="accent1"/>
+          </a:fillRef>
+          <a:effectRef idx="2">
+            <a:schemeClr val="accent1"/>
+          </a:effectRef>
+          <a:fontRef idx="minor">
+            <a:schemeClr val="lt1"/>
+          </a:fontRef>
+        </p:style>
+        <p:txBody>
+          <a:bodyPr rtlCol="0" anchor="ctr"/>
+          <a:lstStyle/>
+          <a:p>
+            <a:pPr algn="ctr"/>
+          </a:p>
+        </p:txBody>
+      </p:sp>
+      <p:sp>
+        <p:nvSpPr>
+          <p:cNvPr id="3" name="Oval 2"/>
+          <p:cNvSpPr/>
+          <p:nvPr/>
+        </p:nvSpPr>
+        <p:spPr>
+          <a:xfrm>
+            <a:off x="8961120" y="3657600"/>
+            <a:ext cx="4572000" cy="4572000"/>
+          </a:xfrm>
+          <a:prstGeom prst="ellipse">
+            <a:avLst/>
+          </a:prstGeom>
+          <a:solidFill>
+            <a:srgbClr val="EC4899"/>
+          </a:solidFill>
+          <a:ln>
+            <a:noFill/>
+          </a:ln>
+        </p:spPr>
+        <p:style>
+          <a:lnRef idx="1">
+            <a:schemeClr val="accent1"/>
+          </a:lnRef>
+          <a:fillRef idx="3">
+            <a:schemeClr val="accent1"/>
+          </a:fillRef>
+          <a:effectRef idx="2">
+            <a:schemeClr val="accent1"/>
+          </a:effectRef>
+          <a:fontRef idx="minor">
+            <a:schemeClr val="lt1"/>
+          </a:fontRef>
+        </p:style>
+        <p:txBody>
+          <a:bodyPr rtlCol="0" anchor="ctr"/>
+          <a:lstStyle/>
+          <a:p>
+            <a:pPr algn="ctr"/>
+          </a:p>
+        </p:txBody>
+      </p:sp>
+      <p:sp>
+        <p:nvSpPr>
+          <p:cNvPr id="4" name="Rounded Rectangle 3"/>
+          <p:cNvSpPr/>
+          <p:nvPr/>
+        </p:nvSpPr>
+        <p:spPr>
+          <a:xfrm>
+            <a:off x="1097280" y="1645920"/>
+            <a:ext cx="9994392" cy="3657600"/>
+          </a:xfrm>
+          <a:prstGeom prst="roundRect">
+            <a:avLst/>
+          </a:prstGeom>
+          <a:solidFill>
+            <a:srgbClr val="16102C"/>
+          </a:solidFill>
+          <a:ln w="25400">
+            <a:solidFill>
+              <a:srgbClr val="7E22CE"/>
+            </a:solidFill>
+          </a:ln>
+        </p:spPr>
+        <p:style>
+          <a:lnRef idx="1">
+            <a:schemeClr val="accent1"/>
+          </a:lnRef>
+          <a:fillRef idx="3">
+            <a:schemeClr val="accent1"/>
+          </a:fillRef>
+          <a:effectRef idx="2">
+            <a:schemeClr val="accent1"/>
+          </a:effectRef>
+          <a:fontRef idx="minor">
+            <a:schemeClr val="lt1"/>
+          </a:fontRef>
+        </p:style>
+        <p:txBody>
+          <a:bodyPr rtlCol="0" anchor="ctr"/>
+          <a:lstStyle/>
+          <a:p>
+            <a:pPr algn="ctr"/>
+          </a:p>
+        </p:txBody>
+      </p:sp>
+      <p:sp>
+        <p:nvSpPr>
+          <p:cNvPr id="5" name="TextBox 4"/>
           <p:cNvSpPr txBox="1"/>
           <p:nvPr/>
         </p:nvSpPr>
         <p:spPr>
           <a:xfrm>
-            <a:off x="914400" y="2011680"/>
-            <a:ext cx="10332720" cy="2743200"/>
+            <a:off x="1463040" y="2011680"/>
+            <a:ext cx="9262872" cy="2926080"/>
           </a:xfrm>
           <a:prstGeom prst="rect">
             <a:avLst/>
@@ -3124,42 +3255,44 @@
           <a:lstStyle/>
           <a:p>
             <a:pPr algn="l">
-              <a:defRPr sz="4800" b="1">
+              <a:defRPr sz="4400" b="1">
+                <a:solidFill>
+                  <a:srgbClr val="06B6D4"/>
+                </a:solidFill>
+                <a:latin typeface="Outfit"/>
+              </a:defRPr>
+            </a:pPr>
+            <a:r>
+              <a:t>PURPLLE STORE INTELLIGENCE</a:t>
+            </a:r>
+          </a:p>
+          <a:p>
+            <a:pPr algn="l">
+              <a:spcAft>
+                <a:spcPts val="3000"/>
+              </a:spcAft>
+              <a:defRPr sz="2000">
+                <a:solidFill>
+                  <a:srgbClr val="FFFFFF"/>
+                </a:solidFill>
+                <a:latin typeface="Outfit"/>
+              </a:defRPr>
+            </a:pPr>
+            <a:r>
+              <a:t>Edge-to-API Computer Vision Telemetry &amp; Retail Analytics Suite</a:t>
+            </a:r>
+          </a:p>
+          <a:p>
+            <a:pPr algn="l">
+              <a:defRPr sz="1300" b="1">
                 <a:solidFill>
                   <a:srgbClr val="EC4899"/>
                 </a:solidFill>
-                <a:latin typeface="Arial"/>
+                <a:latin typeface="Outfit"/>
               </a:defRPr>
             </a:pPr>
             <a:r>
-              <a:t>PURPLLE STORE INTELLIGENCE</a:t>
-            </a:r>
-          </a:p>
-          <a:p>
-            <a:pPr algn="l">
-              <a:defRPr sz="2200">
-                <a:solidFill>
-                  <a:srgbClr val="FFFFFF"/>
-                </a:solidFill>
-                <a:latin typeface="Arial"/>
-              </a:defRPr>
-            </a:pPr>
-            <a:r>
-              <a:t>Edge-to-API Computer Vision Telemetry &amp; Retail Analytics Suite</a:t>
-            </a:r>
-          </a:p>
-          <a:p>
-            <a:br/>
-            <a:pPr algn="l">
-              <a:defRPr sz="1600">
-                <a:solidFill>
-                  <a:srgbClr val="A39CB5"/>
-                </a:solidFill>
-                <a:latin typeface="Arial"/>
-              </a:defRPr>
-            </a:pPr>
-            <a:r>
-              <a:t>Hackathon Submission Pitch Deck</a:t>
+              <a:t>TECHNOLOGY CHALLENGE SUBMISSION PITCH DECK</a:t>
             </a:r>
           </a:p>
         </p:txBody>
@@ -3198,7 +3331,7 @@
         </p:nvSpPr>
         <p:spPr>
           <a:xfrm>
-            <a:off x="731520" y="457200"/>
+            <a:off x="731520" y="365760"/>
             <a:ext cx="10698480" cy="1097280"/>
           </a:xfrm>
           <a:prstGeom prst="rect">
@@ -3207,7 +3340,7 @@
           <a:noFill/>
         </p:spPr>
         <p:txBody>
-          <a:bodyPr wrap="square">
+          <a:bodyPr wrap="square" lIns="0" tIns="0" rIns="0" bIns="0">
             <a:spAutoFit/>
           </a:bodyPr>
           <a:lstStyle/>
@@ -3217,7 +3350,7 @@
                 <a:solidFill>
                   <a:srgbClr val="EC4899"/>
                 </a:solidFill>
-                <a:latin typeface="Arial"/>
+                <a:latin typeface="Outfit"/>
               </a:defRPr>
             </a:pPr>
             <a:r>
@@ -3230,25 +3363,70 @@
                 <a:solidFill>
                   <a:srgbClr val="A39CB5"/>
                 </a:solidFill>
-                <a:latin typeface="Arial"/>
+                <a:latin typeface="Outfit"/>
               </a:defRPr>
             </a:pPr>
             <a:r>
-              <a:t>Why physical retail stores operate in silos</a:t>
-            </a:r>
-          </a:p>
-        </p:txBody>
-      </p:sp>
-      <p:sp>
-        <p:nvSpPr>
-          <p:cNvPr id="3" name="TextBox 2"/>
+              <a:t>Why physical retail stores operate in data silos</a:t>
+            </a:r>
+          </a:p>
+        </p:txBody>
+      </p:sp>
+      <p:sp>
+        <p:nvSpPr>
+          <p:cNvPr id="3" name="Rounded Rectangle 2"/>
+          <p:cNvSpPr/>
+          <p:nvPr/>
+        </p:nvSpPr>
+        <p:spPr>
+          <a:xfrm>
+            <a:off x="731520" y="1828800"/>
+            <a:ext cx="3328416" cy="3840480"/>
+          </a:xfrm>
+          <a:prstGeom prst="roundRect">
+            <a:avLst/>
+          </a:prstGeom>
+          <a:solidFill>
+            <a:srgbClr val="16102C"/>
+          </a:solidFill>
+          <a:ln w="31750">
+            <a:solidFill>
+              <a:srgbClr val="EF4444"/>
+            </a:solidFill>
+          </a:ln>
+        </p:spPr>
+        <p:style>
+          <a:lnRef idx="1">
+            <a:schemeClr val="accent1"/>
+          </a:lnRef>
+          <a:fillRef idx="3">
+            <a:schemeClr val="accent1"/>
+          </a:fillRef>
+          <a:effectRef idx="2">
+            <a:schemeClr val="accent1"/>
+          </a:effectRef>
+          <a:fontRef idx="minor">
+            <a:schemeClr val="lt1"/>
+          </a:fontRef>
+        </p:style>
+        <p:txBody>
+          <a:bodyPr rtlCol="0" anchor="ctr"/>
+          <a:lstStyle/>
+          <a:p>
+            <a:pPr algn="ctr"/>
+          </a:p>
+        </p:txBody>
+      </p:sp>
+      <p:sp>
+        <p:nvSpPr>
+          <p:cNvPr id="4" name="TextBox 3"/>
           <p:cNvSpPr txBox="1"/>
           <p:nvPr/>
         </p:nvSpPr>
         <p:spPr>
           <a:xfrm>
-            <a:off x="731520" y="1828800"/>
-            <a:ext cx="10698480" cy="4114800"/>
+            <a:off x="914400" y="2103120"/>
+            <a:ext cx="2962656" cy="3291840"/>
           </a:xfrm>
           <a:prstGeom prst="rect">
             <a:avLst/>
@@ -3267,24 +3445,99 @@
               </a:spcAft>
               <a:defRPr sz="1800" b="1">
                 <a:solidFill>
-                  <a:srgbClr val="06B6D4"/>
-                </a:solidFill>
-                <a:latin typeface="Arial"/>
+                  <a:srgbClr val="EF4444"/>
+                </a:solidFill>
+                <a:latin typeface="Outfit"/>
               </a:defRPr>
             </a:pPr>
             <a:r>
-              <a:t>•  Siloed Data Systems: </a:t>
-            </a:r>
-            <a:r>
-              <a:rPr sz="1600" b="0">
+              <a:t>SILOED DATA FLOWS</a:t>
+            </a:r>
+          </a:p>
+          <a:p>
+            <a:pPr>
+              <a:lnSpc>
+                <a:spcPct val="130000"/>
+              </a:lnSpc>
+              <a:defRPr sz="1400">
                 <a:solidFill>
                   <a:srgbClr val="FFFFFF"/>
                 </a:solidFill>
-                <a:latin typeface="Arial"/>
-              </a:rPr>
-              <a:t>CCTV video streams and Point-of-Sale (POS) databases do not talk to each other, leaving customer behavior decoupled from final transactions.</a:t>
-            </a:r>
-          </a:p>
+                <a:latin typeface="Outfit"/>
+              </a:defRPr>
+            </a:pPr>
+            <a:r>
+              <a:t>Video feeds from cameras and purchase logs from POS machines do not communicate. Final transactional data is disconnected from in-store customer journeys.</a:t>
+            </a:r>
+          </a:p>
+        </p:txBody>
+      </p:sp>
+      <p:sp>
+        <p:nvSpPr>
+          <p:cNvPr id="5" name="Rounded Rectangle 4"/>
+          <p:cNvSpPr/>
+          <p:nvPr/>
+        </p:nvSpPr>
+        <p:spPr>
+          <a:xfrm>
+            <a:off x="4425696" y="1828800"/>
+            <a:ext cx="3328416" cy="3840480"/>
+          </a:xfrm>
+          <a:prstGeom prst="roundRect">
+            <a:avLst/>
+          </a:prstGeom>
+          <a:solidFill>
+            <a:srgbClr val="16102C"/>
+          </a:solidFill>
+          <a:ln w="31750">
+            <a:solidFill>
+              <a:srgbClr val="F97316"/>
+            </a:solidFill>
+          </a:ln>
+        </p:spPr>
+        <p:style>
+          <a:lnRef idx="1">
+            <a:schemeClr val="accent1"/>
+          </a:lnRef>
+          <a:fillRef idx="3">
+            <a:schemeClr val="accent1"/>
+          </a:fillRef>
+          <a:effectRef idx="2">
+            <a:schemeClr val="accent1"/>
+          </a:effectRef>
+          <a:fontRef idx="minor">
+            <a:schemeClr val="lt1"/>
+          </a:fontRef>
+        </p:style>
+        <p:txBody>
+          <a:bodyPr rtlCol="0" anchor="ctr"/>
+          <a:lstStyle/>
+          <a:p>
+            <a:pPr algn="ctr"/>
+          </a:p>
+        </p:txBody>
+      </p:sp>
+      <p:sp>
+        <p:nvSpPr>
+          <p:cNvPr id="6" name="TextBox 5"/>
+          <p:cNvSpPr txBox="1"/>
+          <p:nvPr/>
+        </p:nvSpPr>
+        <p:spPr>
+          <a:xfrm>
+            <a:off x="4608576" y="2103120"/>
+            <a:ext cx="2962656" cy="3291840"/>
+          </a:xfrm>
+          <a:prstGeom prst="rect">
+            <a:avLst/>
+          </a:prstGeom>
+          <a:noFill/>
+        </p:spPr>
+        <p:txBody>
+          <a:bodyPr wrap="square">
+            <a:spAutoFit/>
+          </a:bodyPr>
+          <a:lstStyle/>
           <a:p>
             <a:pPr>
               <a:spcAft>
@@ -3292,24 +3545,99 @@
               </a:spcAft>
               <a:defRPr sz="1800" b="1">
                 <a:solidFill>
-                  <a:srgbClr val="06B6D4"/>
-                </a:solidFill>
-                <a:latin typeface="Arial"/>
+                  <a:srgbClr val="F97316"/>
+                </a:solidFill>
+                <a:latin typeface="Outfit"/>
               </a:defRPr>
             </a:pPr>
             <a:r>
-              <a:t>•  Dark-Spot Tracking: </a:t>
-            </a:r>
-            <a:r>
-              <a:rPr sz="1600" b="0">
+              <a:t>TRACKING BLINDSPOTS</a:t>
+            </a:r>
+          </a:p>
+          <a:p>
+            <a:pPr>
+              <a:lnSpc>
+                <a:spcPct val="130000"/>
+              </a:lnSpc>
+              <a:defRPr sz="1400">
                 <a:solidFill>
                   <a:srgbClr val="FFFFFF"/>
                 </a:solidFill>
-                <a:latin typeface="Arial"/>
-              </a:rPr>
-              <a:t>Stores have zero metrics on customer journeys. They do not know how many unique visitors browse shelves, where drop-offs happen, or how long people wait in checkout lines.</a:t>
-            </a:r>
-          </a:p>
+                <a:latin typeface="Outfit"/>
+              </a:defRPr>
+            </a:pPr>
+            <a:r>
+              <a:t>Retailers have zero metrics on how many unique visitors browse displays, which zones receive the highest dwell time, or where customers drop out of checkout lines.</a:t>
+            </a:r>
+          </a:p>
+        </p:txBody>
+      </p:sp>
+      <p:sp>
+        <p:nvSpPr>
+          <p:cNvPr id="7" name="Rounded Rectangle 6"/>
+          <p:cNvSpPr/>
+          <p:nvPr/>
+        </p:nvSpPr>
+        <p:spPr>
+          <a:xfrm>
+            <a:off x="8119872" y="1828800"/>
+            <a:ext cx="3328416" cy="3840480"/>
+          </a:xfrm>
+          <a:prstGeom prst="roundRect">
+            <a:avLst/>
+          </a:prstGeom>
+          <a:solidFill>
+            <a:srgbClr val="16102C"/>
+          </a:solidFill>
+          <a:ln w="31750">
+            <a:solidFill>
+              <a:srgbClr val="7E22CE"/>
+            </a:solidFill>
+          </a:ln>
+        </p:spPr>
+        <p:style>
+          <a:lnRef idx="1">
+            <a:schemeClr val="accent1"/>
+          </a:lnRef>
+          <a:fillRef idx="3">
+            <a:schemeClr val="accent1"/>
+          </a:fillRef>
+          <a:effectRef idx="2">
+            <a:schemeClr val="accent1"/>
+          </a:effectRef>
+          <a:fontRef idx="minor">
+            <a:schemeClr val="lt1"/>
+          </a:fontRef>
+        </p:style>
+        <p:txBody>
+          <a:bodyPr rtlCol="0" anchor="ctr"/>
+          <a:lstStyle/>
+          <a:p>
+            <a:pPr algn="ctr"/>
+          </a:p>
+        </p:txBody>
+      </p:sp>
+      <p:sp>
+        <p:nvSpPr>
+          <p:cNvPr id="8" name="TextBox 7"/>
+          <p:cNvSpPr txBox="1"/>
+          <p:nvPr/>
+        </p:nvSpPr>
+        <p:spPr>
+          <a:xfrm>
+            <a:off x="8302752" y="2103120"/>
+            <a:ext cx="2962656" cy="3291840"/>
+          </a:xfrm>
+          <a:prstGeom prst="rect">
+            <a:avLst/>
+          </a:prstGeom>
+          <a:noFill/>
+        </p:spPr>
+        <p:txBody>
+          <a:bodyPr wrap="square">
+            <a:spAutoFit/>
+          </a:bodyPr>
+          <a:lstStyle/>
           <a:p>
             <a:pPr>
               <a:spcAft>
@@ -3317,47 +3645,29 @@
               </a:spcAft>
               <a:defRPr sz="1800" b="1">
                 <a:solidFill>
-                  <a:srgbClr val="06B6D4"/>
-                </a:solidFill>
-                <a:latin typeface="Arial"/>
+                  <a:srgbClr val="7E22CE"/>
+                </a:solidFill>
+                <a:latin typeface="Outfit"/>
               </a:defRPr>
             </a:pPr>
             <a:r>
-              <a:t>•  Operational Inefficiencies: </a:t>
-            </a:r>
-            <a:r>
-              <a:rPr sz="1600" b="0">
+              <a:t>OPERATIONAL INACTION</a:t>
+            </a:r>
+          </a:p>
+          <a:p>
+            <a:pPr>
+              <a:lnSpc>
+                <a:spcPct val="130000"/>
+              </a:lnSpc>
+              <a:defRPr sz="1400">
                 <a:solidFill>
                   <a:srgbClr val="FFFFFF"/>
                 </a:solidFill>
-                <a:latin typeface="Arial"/>
-              </a:rPr>
-              <a:t>Managers lack real-time indicators for billing queue abandonment, layout congestion, or low store conversion rates.</a:t>
-            </a:r>
-          </a:p>
-          <a:p>
-            <a:pPr>
-              <a:spcAft>
-                <a:spcPts val="2000"/>
-              </a:spcAft>
-              <a:defRPr sz="1800" b="1">
-                <a:solidFill>
-                  <a:srgbClr val="06B6D4"/>
-                </a:solidFill>
-                <a:latin typeface="Arial"/>
+                <a:latin typeface="Outfit"/>
               </a:defRPr>
             </a:pPr>
             <a:r>
-              <a:t>•  Data Timeline Mismatches: </a:t>
-            </a:r>
-            <a:r>
-              <a:rPr sz="1600" b="0">
-                <a:solidFill>
-                  <a:srgbClr val="FFFFFF"/>
-                </a:solidFill>
-                <a:latin typeface="Arial"/>
-              </a:rPr>
-              <a:t>Aggregating historical telemetry and mock evaluation datasets with mismatched timelines is mathematically complex and error-prone.</a:t>
+              <a:t>Store managers lack real-time triggers for long billing wait times, queue spikes, or customer line abandonments, causing unnoticed conversions drops.</a:t>
             </a:r>
           </a:p>
         </p:txBody>
@@ -3396,7 +3706,7 @@
         </p:nvSpPr>
         <p:spPr>
           <a:xfrm>
-            <a:off x="731520" y="457200"/>
+            <a:off x="731520" y="365760"/>
             <a:ext cx="10698480" cy="1097280"/>
           </a:xfrm>
           <a:prstGeom prst="rect">
@@ -3405,7 +3715,7 @@
           <a:noFill/>
         </p:spPr>
         <p:txBody>
-          <a:bodyPr wrap="square">
+          <a:bodyPr wrap="square" lIns="0" tIns="0" rIns="0" bIns="0">
             <a:spAutoFit/>
           </a:bodyPr>
           <a:lstStyle/>
@@ -3415,11 +3725,11 @@
                 <a:solidFill>
                   <a:srgbClr val="EC4899"/>
                 </a:solidFill>
-                <a:latin typeface="Arial"/>
+                <a:latin typeface="Outfit"/>
               </a:defRPr>
             </a:pPr>
             <a:r>
-              <a:t>THE DECOUPLED EDGE-TO-API SOLUTION</a:t>
+              <a:t>SYSTEM ARCHITECTURE FLOW</a:t>
             </a:r>
           </a:p>
           <a:p>
@@ -3428,25 +3738,70 @@
                 <a:solidFill>
                   <a:srgbClr val="A39CB5"/>
                 </a:solidFill>
-                <a:latin typeface="Arial"/>
+                <a:latin typeface="Outfit"/>
               </a:defRPr>
             </a:pPr>
             <a:r>
-              <a:t>End-to-end retail intelligence architecture</a:t>
-            </a:r>
-          </a:p>
-        </p:txBody>
-      </p:sp>
-      <p:sp>
-        <p:nvSpPr>
-          <p:cNvPr id="3" name="TextBox 2"/>
+              <a:t>Decoupled edge client streaming to compliant analytics endpoints</a:t>
+            </a:r>
+          </a:p>
+        </p:txBody>
+      </p:sp>
+      <p:sp>
+        <p:nvSpPr>
+          <p:cNvPr id="3" name="Rounded Rectangle 2"/>
+          <p:cNvSpPr/>
+          <p:nvPr/>
+        </p:nvSpPr>
+        <p:spPr>
+          <a:xfrm>
+            <a:off x="731520" y="2560320"/>
+            <a:ext cx="2011680" cy="2194560"/>
+          </a:xfrm>
+          <a:prstGeom prst="roundRect">
+            <a:avLst/>
+          </a:prstGeom>
+          <a:solidFill>
+            <a:srgbClr val="16102C"/>
+          </a:solidFill>
+          <a:ln w="38100">
+            <a:solidFill>
+              <a:srgbClr val="06B6D4"/>
+            </a:solidFill>
+          </a:ln>
+        </p:spPr>
+        <p:style>
+          <a:lnRef idx="1">
+            <a:schemeClr val="accent1"/>
+          </a:lnRef>
+          <a:fillRef idx="3">
+            <a:schemeClr val="accent1"/>
+          </a:fillRef>
+          <a:effectRef idx="2">
+            <a:schemeClr val="accent1"/>
+          </a:effectRef>
+          <a:fontRef idx="minor">
+            <a:schemeClr val="lt1"/>
+          </a:fontRef>
+        </p:style>
+        <p:txBody>
+          <a:bodyPr rtlCol="0" anchor="ctr"/>
+          <a:lstStyle/>
+          <a:p>
+            <a:pPr algn="ctr"/>
+          </a:p>
+        </p:txBody>
+      </p:sp>
+      <p:sp>
+        <p:nvSpPr>
+          <p:cNvPr id="4" name="TextBox 3"/>
           <p:cNvSpPr txBox="1"/>
           <p:nvPr/>
         </p:nvSpPr>
         <p:spPr>
           <a:xfrm>
-            <a:off x="731520" y="1828800"/>
-            <a:ext cx="10698480" cy="4114800"/>
+            <a:off x="822960" y="2743200"/>
+            <a:ext cx="1828800" cy="1828800"/>
           </a:xfrm>
           <a:prstGeom prst="rect">
             <a:avLst/>
@@ -3459,103 +3814,480 @@
           </a:bodyPr>
           <a:lstStyle/>
           <a:p>
-            <a:pPr>
+            <a:pPr algn="ctr">
               <a:spcAft>
-                <a:spcPts val="2000"/>
+                <a:spcPts val="1200"/>
               </a:spcAft>
-              <a:defRPr sz="1800" b="1">
+              <a:defRPr sz="1400" b="1">
+                <a:solidFill>
+                  <a:srgbClr val="06B6D4"/>
+                </a:solidFill>
+                <a:latin typeface="Outfit"/>
+              </a:defRPr>
+            </a:pPr>
+            <a:r>
+              <a:t>EDGE VIDEO</a:t>
+            </a:r>
+            <a:br/>
+            <a:r>
+              <a:t>CCTV FEEDS</a:t>
+            </a:r>
+          </a:p>
+          <a:p>
+            <a:pPr algn="ctr">
+              <a:lnSpc>
+                <a:spcPct val="120000"/>
+              </a:lnSpc>
+              <a:defRPr sz="1100">
+                <a:solidFill>
+                  <a:srgbClr val="FFFFFF"/>
+                </a:solidFill>
+                <a:latin typeface="Outfit"/>
+              </a:defRPr>
+            </a:pPr>
+            <a:r>
+              <a:t>Processes CCTV video feeds frame-by-frame locally. Utilizes YOLOv8 for human bounding box detection.</a:t>
+            </a:r>
+          </a:p>
+        </p:txBody>
+      </p:sp>
+      <p:sp>
+        <p:nvSpPr>
+          <p:cNvPr id="5" name="Right Arrow 4"/>
+          <p:cNvSpPr/>
+          <p:nvPr/>
+        </p:nvSpPr>
+        <p:spPr>
+          <a:xfrm>
+            <a:off x="2788920" y="3429000"/>
+            <a:ext cx="548640" cy="457200"/>
+          </a:xfrm>
+          <a:prstGeom prst="rightArrow">
+            <a:avLst/>
+          </a:prstGeom>
+          <a:solidFill>
+            <a:srgbClr val="EC4899"/>
+          </a:solidFill>
+          <a:ln>
+            <a:noFill/>
+          </a:ln>
+        </p:spPr>
+        <p:style>
+          <a:lnRef idx="1">
+            <a:schemeClr val="accent1"/>
+          </a:lnRef>
+          <a:fillRef idx="3">
+            <a:schemeClr val="accent1"/>
+          </a:fillRef>
+          <a:effectRef idx="2">
+            <a:schemeClr val="accent1"/>
+          </a:effectRef>
+          <a:fontRef idx="minor">
+            <a:schemeClr val="lt1"/>
+          </a:fontRef>
+        </p:style>
+        <p:txBody>
+          <a:bodyPr rtlCol="0" anchor="ctr"/>
+          <a:lstStyle/>
+          <a:p>
+            <a:pPr algn="ctr"/>
+          </a:p>
+        </p:txBody>
+      </p:sp>
+      <p:sp>
+        <p:nvSpPr>
+          <p:cNvPr id="6" name="Rounded Rectangle 5"/>
+          <p:cNvSpPr/>
+          <p:nvPr/>
+        </p:nvSpPr>
+        <p:spPr>
+          <a:xfrm>
+            <a:off x="3931920" y="2560320"/>
+            <a:ext cx="2011680" cy="2194560"/>
+          </a:xfrm>
+          <a:prstGeom prst="roundRect">
+            <a:avLst/>
+          </a:prstGeom>
+          <a:solidFill>
+            <a:srgbClr val="16102C"/>
+          </a:solidFill>
+          <a:ln w="38100">
+            <a:solidFill>
+              <a:srgbClr val="7E22CE"/>
+            </a:solidFill>
+          </a:ln>
+        </p:spPr>
+        <p:style>
+          <a:lnRef idx="1">
+            <a:schemeClr val="accent1"/>
+          </a:lnRef>
+          <a:fillRef idx="3">
+            <a:schemeClr val="accent1"/>
+          </a:fillRef>
+          <a:effectRef idx="2">
+            <a:schemeClr val="accent1"/>
+          </a:effectRef>
+          <a:fontRef idx="minor">
+            <a:schemeClr val="lt1"/>
+          </a:fontRef>
+        </p:style>
+        <p:txBody>
+          <a:bodyPr rtlCol="0" anchor="ctr"/>
+          <a:lstStyle/>
+          <a:p>
+            <a:pPr algn="ctr"/>
+          </a:p>
+        </p:txBody>
+      </p:sp>
+      <p:sp>
+        <p:nvSpPr>
+          <p:cNvPr id="7" name="TextBox 6"/>
+          <p:cNvSpPr txBox="1"/>
+          <p:nvPr/>
+        </p:nvSpPr>
+        <p:spPr>
+          <a:xfrm>
+            <a:off x="4023360" y="2743200"/>
+            <a:ext cx="1828800" cy="1828800"/>
+          </a:xfrm>
+          <a:prstGeom prst="rect">
+            <a:avLst/>
+          </a:prstGeom>
+          <a:noFill/>
+        </p:spPr>
+        <p:txBody>
+          <a:bodyPr wrap="square">
+            <a:spAutoFit/>
+          </a:bodyPr>
+          <a:lstStyle/>
+          <a:p>
+            <a:pPr algn="ctr">
+              <a:spcAft>
+                <a:spcPts val="1200"/>
+              </a:spcAft>
+              <a:defRPr sz="1400" b="1">
+                <a:solidFill>
+                  <a:srgbClr val="7E22CE"/>
+                </a:solidFill>
+                <a:latin typeface="Outfit"/>
+              </a:defRPr>
+            </a:pPr>
+            <a:r>
+              <a:t>CV PIPELINE</a:t>
+            </a:r>
+            <a:br/>
+            <a:r>
+              <a:t>TRACKER ENGINE</a:t>
+            </a:r>
+          </a:p>
+          <a:p>
+            <a:pPr algn="ctr">
+              <a:lnSpc>
+                <a:spcPct val="120000"/>
+              </a:lnSpc>
+              <a:defRPr sz="1100">
+                <a:solidFill>
+                  <a:srgbClr val="FFFFFF"/>
+                </a:solidFill>
+                <a:latin typeface="Outfit"/>
+              </a:defRPr>
+            </a:pPr>
+            <a:r>
+              <a:t>Maps centroids &amp; IoU overlaps. Translates shopper footprint positions to store zones (cv2.pointPolygonTest).</a:t>
+            </a:r>
+          </a:p>
+        </p:txBody>
+      </p:sp>
+      <p:sp>
+        <p:nvSpPr>
+          <p:cNvPr id="8" name="Right Arrow 7"/>
+          <p:cNvSpPr/>
+          <p:nvPr/>
+        </p:nvSpPr>
+        <p:spPr>
+          <a:xfrm>
+            <a:off x="5989320" y="3429000"/>
+            <a:ext cx="548640" cy="457200"/>
+          </a:xfrm>
+          <a:prstGeom prst="rightArrow">
+            <a:avLst/>
+          </a:prstGeom>
+          <a:solidFill>
+            <a:srgbClr val="EC4899"/>
+          </a:solidFill>
+          <a:ln>
+            <a:noFill/>
+          </a:ln>
+        </p:spPr>
+        <p:style>
+          <a:lnRef idx="1">
+            <a:schemeClr val="accent1"/>
+          </a:lnRef>
+          <a:fillRef idx="3">
+            <a:schemeClr val="accent1"/>
+          </a:fillRef>
+          <a:effectRef idx="2">
+            <a:schemeClr val="accent1"/>
+          </a:effectRef>
+          <a:fontRef idx="minor">
+            <a:schemeClr val="lt1"/>
+          </a:fontRef>
+        </p:style>
+        <p:txBody>
+          <a:bodyPr rtlCol="0" anchor="ctr"/>
+          <a:lstStyle/>
+          <a:p>
+            <a:pPr algn="ctr"/>
+          </a:p>
+        </p:txBody>
+      </p:sp>
+      <p:sp>
+        <p:nvSpPr>
+          <p:cNvPr id="9" name="Rounded Rectangle 8"/>
+          <p:cNvSpPr/>
+          <p:nvPr/>
+        </p:nvSpPr>
+        <p:spPr>
+          <a:xfrm>
+            <a:off x="7132320" y="2560320"/>
+            <a:ext cx="2011680" cy="2194560"/>
+          </a:xfrm>
+          <a:prstGeom prst="roundRect">
+            <a:avLst/>
+          </a:prstGeom>
+          <a:solidFill>
+            <a:srgbClr val="16102C"/>
+          </a:solidFill>
+          <a:ln w="38100">
+            <a:solidFill>
+              <a:srgbClr val="EC4899"/>
+            </a:solidFill>
+          </a:ln>
+        </p:spPr>
+        <p:style>
+          <a:lnRef idx="1">
+            <a:schemeClr val="accent1"/>
+          </a:lnRef>
+          <a:fillRef idx="3">
+            <a:schemeClr val="accent1"/>
+          </a:fillRef>
+          <a:effectRef idx="2">
+            <a:schemeClr val="accent1"/>
+          </a:effectRef>
+          <a:fontRef idx="minor">
+            <a:schemeClr val="lt1"/>
+          </a:fontRef>
+        </p:style>
+        <p:txBody>
+          <a:bodyPr rtlCol="0" anchor="ctr"/>
+          <a:lstStyle/>
+          <a:p>
+            <a:pPr algn="ctr"/>
+          </a:p>
+        </p:txBody>
+      </p:sp>
+      <p:sp>
+        <p:nvSpPr>
+          <p:cNvPr id="10" name="TextBox 9"/>
+          <p:cNvSpPr txBox="1"/>
+          <p:nvPr/>
+        </p:nvSpPr>
+        <p:spPr>
+          <a:xfrm>
+            <a:off x="7223760" y="2743200"/>
+            <a:ext cx="1828800" cy="1828800"/>
+          </a:xfrm>
+          <a:prstGeom prst="rect">
+            <a:avLst/>
+          </a:prstGeom>
+          <a:noFill/>
+        </p:spPr>
+        <p:txBody>
+          <a:bodyPr wrap="square">
+            <a:spAutoFit/>
+          </a:bodyPr>
+          <a:lstStyle/>
+          <a:p>
+            <a:pPr algn="ctr">
+              <a:spcAft>
+                <a:spcPts val="1200"/>
+              </a:spcAft>
+              <a:defRPr sz="1400" b="1">
                 <a:solidFill>
                   <a:srgbClr val="EC4899"/>
                 </a:solidFill>
-                <a:latin typeface="Arial"/>
+                <a:latin typeface="Outfit"/>
               </a:defRPr>
             </a:pPr>
             <a:r>
-              <a:t>•  YOLOv8 &amp; Custom Tracking Client: </a:t>
-            </a:r>
-            <a:r>
-              <a:rPr sz="1600" b="0">
+              <a:t>FASTAPI GATEWAY</a:t>
+            </a:r>
+            <a:br/>
+            <a:r>
+              <a:t>STORAGE SERVER</a:t>
+            </a:r>
+          </a:p>
+          <a:p>
+            <a:pPr algn="ctr">
+              <a:lnSpc>
+                <a:spcPct val="120000"/>
+              </a:lnSpc>
+              <a:defRPr sz="1100">
                 <a:solidFill>
                   <a:srgbClr val="FFFFFF"/>
                 </a:solidFill>
-                <a:latin typeface="Arial"/>
-              </a:rPr>
-              <a:t>Processes raw camera video clips locally, extracts coordinates, and tracks shopper centroids with an IoU matching layer to maintain ID continuity during occlusions.</a:t>
-            </a:r>
-          </a:p>
-          <a:p>
-            <a:pPr>
+                <a:latin typeface="Outfit"/>
+              </a:defRPr>
+            </a:pPr>
+            <a:r>
+              <a:t>Validates schema. Runs SQLite constraint deduplication, and boots POS CSV transactions data.</a:t>
+            </a:r>
+          </a:p>
+        </p:txBody>
+      </p:sp>
+      <p:sp>
+        <p:nvSpPr>
+          <p:cNvPr id="11" name="Right Arrow 10"/>
+          <p:cNvSpPr/>
+          <p:nvPr/>
+        </p:nvSpPr>
+        <p:spPr>
+          <a:xfrm>
+            <a:off x="9189720" y="3429000"/>
+            <a:ext cx="548640" cy="457200"/>
+          </a:xfrm>
+          <a:prstGeom prst="rightArrow">
+            <a:avLst/>
+          </a:prstGeom>
+          <a:solidFill>
+            <a:srgbClr val="EC4899"/>
+          </a:solidFill>
+          <a:ln>
+            <a:noFill/>
+          </a:ln>
+        </p:spPr>
+        <p:style>
+          <a:lnRef idx="1">
+            <a:schemeClr val="accent1"/>
+          </a:lnRef>
+          <a:fillRef idx="3">
+            <a:schemeClr val="accent1"/>
+          </a:fillRef>
+          <a:effectRef idx="2">
+            <a:schemeClr val="accent1"/>
+          </a:effectRef>
+          <a:fontRef idx="minor">
+            <a:schemeClr val="lt1"/>
+          </a:fontRef>
+        </p:style>
+        <p:txBody>
+          <a:bodyPr rtlCol="0" anchor="ctr"/>
+          <a:lstStyle/>
+          <a:p>
+            <a:pPr algn="ctr"/>
+          </a:p>
+        </p:txBody>
+      </p:sp>
+      <p:sp>
+        <p:nvSpPr>
+          <p:cNvPr id="12" name="Rounded Rectangle 11"/>
+          <p:cNvSpPr/>
+          <p:nvPr/>
+        </p:nvSpPr>
+        <p:spPr>
+          <a:xfrm>
+            <a:off x="10332720" y="2560320"/>
+            <a:ext cx="2011680" cy="2194560"/>
+          </a:xfrm>
+          <a:prstGeom prst="roundRect">
+            <a:avLst/>
+          </a:prstGeom>
+          <a:solidFill>
+            <a:srgbClr val="16102C"/>
+          </a:solidFill>
+          <a:ln w="38100">
+            <a:solidFill>
+              <a:srgbClr val="10B981"/>
+            </a:solidFill>
+          </a:ln>
+        </p:spPr>
+        <p:style>
+          <a:lnRef idx="1">
+            <a:schemeClr val="accent1"/>
+          </a:lnRef>
+          <a:fillRef idx="3">
+            <a:schemeClr val="accent1"/>
+          </a:fillRef>
+          <a:effectRef idx="2">
+            <a:schemeClr val="accent1"/>
+          </a:effectRef>
+          <a:fontRef idx="minor">
+            <a:schemeClr val="lt1"/>
+          </a:fontRef>
+        </p:style>
+        <p:txBody>
+          <a:bodyPr rtlCol="0" anchor="ctr"/>
+          <a:lstStyle/>
+          <a:p>
+            <a:pPr algn="ctr"/>
+          </a:p>
+        </p:txBody>
+      </p:sp>
+      <p:sp>
+        <p:nvSpPr>
+          <p:cNvPr id="13" name="TextBox 12"/>
+          <p:cNvSpPr txBox="1"/>
+          <p:nvPr/>
+        </p:nvSpPr>
+        <p:spPr>
+          <a:xfrm>
+            <a:off x="10424160" y="2743200"/>
+            <a:ext cx="1828800" cy="1828800"/>
+          </a:xfrm>
+          <a:prstGeom prst="rect">
+            <a:avLst/>
+          </a:prstGeom>
+          <a:noFill/>
+        </p:spPr>
+        <p:txBody>
+          <a:bodyPr wrap="square">
+            <a:spAutoFit/>
+          </a:bodyPr>
+          <a:lstStyle/>
+          <a:p>
+            <a:pPr algn="ctr">
               <a:spcAft>
-                <a:spcPts val="2000"/>
+                <a:spcPts val="1200"/>
               </a:spcAft>
-              <a:defRPr sz="1800" b="1">
-                <a:solidFill>
-                  <a:srgbClr val="EC4899"/>
-                </a:solidFill>
-                <a:latin typeface="Arial"/>
+              <a:defRPr sz="1400" b="1">
+                <a:solidFill>
+                  <a:srgbClr val="10B981"/>
+                </a:solidFill>
+                <a:latin typeface="Outfit"/>
               </a:defRPr>
             </a:pPr>
             <a:r>
-              <a:t>•  FastAPI Analytics Gateway: </a:t>
-            </a:r>
-            <a:r>
-              <a:rPr sz="1600" b="0">
+              <a:t>ANALYTICS</a:t>
+            </a:r>
+            <a:br/>
+            <a:r>
+              <a:t>WEB UI</a:t>
+            </a:r>
+          </a:p>
+          <a:p>
+            <a:pPr algn="ctr">
+              <a:lnSpc>
+                <a:spcPct val="120000"/>
+              </a:lnSpc>
+              <a:defRPr sz="1100">
                 <a:solidFill>
                   <a:srgbClr val="FFFFFF"/>
                 </a:solidFill>
-                <a:latin typeface="Arial"/>
-              </a:rPr>
-              <a:t>A high-performance REST API supporting idempotent event ingest batches (up to 500 events) and path parameter query endpoints (/stores/{id}/metrics).</a:t>
-            </a:r>
-          </a:p>
-          <a:p>
-            <a:pPr>
-              <a:spcAft>
-                <a:spcPts val="2000"/>
-              </a:spcAft>
-              <a:defRPr sz="1800" b="1">
-                <a:solidFill>
-                  <a:srgbClr val="EC4899"/>
-                </a:solidFill>
-                <a:latin typeface="Arial"/>
+                <a:latin typeface="Outfit"/>
               </a:defRPr>
             </a:pPr>
             <a:r>
-              <a:t>•  Idempotent SQLite Engine: </a:t>
-            </a:r>
-            <a:r>
-              <a:rPr sz="1600" b="0">
-                <a:solidFill>
-                  <a:srgbClr val="FFFFFF"/>
-                </a:solidFill>
-                <a:latin typeface="Arial"/>
-              </a:rPr>
-              <a:t>Maintains zero-config storage. Resolves network retries and feed overlaps directly at database-level via unique constraint deduplication.</a:t>
-            </a:r>
-          </a:p>
-          <a:p>
-            <a:pPr>
-              <a:spcAft>
-                <a:spcPts val="2000"/>
-              </a:spcAft>
-              <a:defRPr sz="1800" b="1">
-                <a:solidFill>
-                  <a:srgbClr val="EC4899"/>
-                </a:solidFill>
-                <a:latin typeface="Arial"/>
-              </a:defRPr>
-            </a:pPr>
-            <a:r>
-              <a:t>•  Glassmorphic Telemetry Dashboard: </a:t>
-            </a:r>
-            <a:r>
-              <a:rPr sz="1600" b="0">
-                <a:solidFill>
-                  <a:srgbClr val="FFFFFF"/>
-                </a:solidFill>
-                <a:latin typeface="Arial"/>
-              </a:rPr>
-              <a:t>Refreshes every 5 seconds to provide visual conversion funnel metrics, zone heatmap statistics, queue counts, and operational alerts.</a:t>
+              <a:t>Computes conversions, funnels, and alert notifications. Refreshes live metrics every 5 seconds.</a:t>
             </a:r>
           </a:p>
         </p:txBody>
@@ -3594,7 +4326,7 @@
         </p:nvSpPr>
         <p:spPr>
           <a:xfrm>
-            <a:off x="731520" y="457200"/>
+            <a:off x="731520" y="365760"/>
             <a:ext cx="10698480" cy="1097280"/>
           </a:xfrm>
           <a:prstGeom prst="rect">
@@ -3603,7 +4335,7 @@
           <a:noFill/>
         </p:spPr>
         <p:txBody>
-          <a:bodyPr wrap="square">
+          <a:bodyPr wrap="square" lIns="0" tIns="0" rIns="0" bIns="0">
             <a:spAutoFit/>
           </a:bodyPr>
           <a:lstStyle/>
@@ -3613,11 +4345,11 @@
                 <a:solidFill>
                   <a:srgbClr val="EC4899"/>
                 </a:solidFill>
-                <a:latin typeface="Arial"/>
+                <a:latin typeface="Outfit"/>
               </a:defRPr>
             </a:pPr>
             <a:r>
-              <a:t>DEEP RETAIL KPIS &amp; ANALYTICS</a:t>
+              <a:t>VISITOR CONVERSION FUNNEL</a:t>
             </a:r>
           </a:p>
           <a:p>
@@ -3626,25 +4358,70 @@
                 <a:solidFill>
                   <a:srgbClr val="A39CB5"/>
                 </a:solidFill>
-                <a:latin typeface="Arial"/>
+                <a:latin typeface="Outfit"/>
               </a:defRPr>
             </a:pPr>
             <a:r>
-              <a:t>Turning raw logs into conversion pipelines</a:t>
-            </a:r>
-          </a:p>
-        </p:txBody>
-      </p:sp>
-      <p:sp>
-        <p:nvSpPr>
-          <p:cNvPr id="3" name="TextBox 2"/>
+              <a:t>Session-based, deduplicated shopper conversion journey</a:t>
+            </a:r>
+          </a:p>
+        </p:txBody>
+      </p:sp>
+      <p:sp>
+        <p:nvSpPr>
+          <p:cNvPr id="3" name="Rectangle 2"/>
+          <p:cNvSpPr/>
+          <p:nvPr/>
+        </p:nvSpPr>
+        <p:spPr>
+          <a:xfrm>
+            <a:off x="731520" y="2011680"/>
+            <a:ext cx="4114800" cy="914400"/>
+          </a:xfrm>
+          <a:prstGeom prst="rect">
+            <a:avLst/>
+          </a:prstGeom>
+          <a:solidFill>
+            <a:srgbClr val="16102C"/>
+          </a:solidFill>
+          <a:ln w="31750">
+            <a:solidFill>
+              <a:srgbClr val="06B6D4"/>
+            </a:solidFill>
+          </a:ln>
+        </p:spPr>
+        <p:style>
+          <a:lnRef idx="1">
+            <a:schemeClr val="accent1"/>
+          </a:lnRef>
+          <a:fillRef idx="3">
+            <a:schemeClr val="accent1"/>
+          </a:fillRef>
+          <a:effectRef idx="2">
+            <a:schemeClr val="accent1"/>
+          </a:effectRef>
+          <a:fontRef idx="minor">
+            <a:schemeClr val="lt1"/>
+          </a:fontRef>
+        </p:style>
+        <p:txBody>
+          <a:bodyPr rtlCol="0" anchor="ctr"/>
+          <a:lstStyle/>
+          <a:p>
+            <a:pPr algn="ctr"/>
+          </a:p>
+        </p:txBody>
+      </p:sp>
+      <p:sp>
+        <p:nvSpPr>
+          <p:cNvPr id="4" name="TextBox 3"/>
           <p:cNvSpPr txBox="1"/>
           <p:nvPr/>
         </p:nvSpPr>
         <p:spPr>
           <a:xfrm>
-            <a:off x="731520" y="1828800"/>
-            <a:ext cx="10698480" cy="4114800"/>
+            <a:off x="868680" y="2148840"/>
+            <a:ext cx="3840480" cy="640080"/>
           </a:xfrm>
           <a:prstGeom prst="rect">
             <a:avLst/>
@@ -3657,103 +4434,583 @@
           </a:bodyPr>
           <a:lstStyle/>
           <a:p>
-            <a:pPr>
-              <a:spcAft>
-                <a:spcPts val="2000"/>
-              </a:spcAft>
-              <a:defRPr sz="1800" b="1">
+            <a:pPr algn="l">
+              <a:defRPr sz="1400" b="1">
                 <a:solidFill>
                   <a:srgbClr val="06B6D4"/>
                 </a:solidFill>
-                <a:latin typeface="Arial"/>
+                <a:latin typeface="Outfit"/>
               </a:defRPr>
             </a:pPr>
             <a:r>
-              <a:t>•  Store Conversion Rates: </a:t>
-            </a:r>
-            <a:r>
-              <a:rPr sz="1600" b="0">
+              <a:t>STAGE 1: ENTRANCE VISITORS (100%)</a:t>
+            </a:r>
+          </a:p>
+        </p:txBody>
+      </p:sp>
+      <p:sp>
+        <p:nvSpPr>
+          <p:cNvPr id="5" name="Rectangle 4"/>
+          <p:cNvSpPr/>
+          <p:nvPr/>
+        </p:nvSpPr>
+        <p:spPr>
+          <a:xfrm>
+            <a:off x="5120640" y="2011680"/>
+            <a:ext cx="6336792" cy="914400"/>
+          </a:xfrm>
+          <a:prstGeom prst="rect">
+            <a:avLst/>
+          </a:prstGeom>
+          <a:solidFill>
+            <a:srgbClr val="16102C"/>
+          </a:solidFill>
+          <a:ln w="12700">
+            <a:solidFill>
+              <a:srgbClr val="7E22CE"/>
+            </a:solidFill>
+          </a:ln>
+        </p:spPr>
+        <p:style>
+          <a:lnRef idx="1">
+            <a:schemeClr val="accent1"/>
+          </a:lnRef>
+          <a:fillRef idx="3">
+            <a:schemeClr val="accent1"/>
+          </a:fillRef>
+          <a:effectRef idx="2">
+            <a:schemeClr val="accent1"/>
+          </a:effectRef>
+          <a:fontRef idx="minor">
+            <a:schemeClr val="lt1"/>
+          </a:fontRef>
+        </p:style>
+        <p:txBody>
+          <a:bodyPr rtlCol="0" anchor="ctr"/>
+          <a:lstStyle/>
+          <a:p>
+            <a:pPr algn="ctr"/>
+          </a:p>
+        </p:txBody>
+      </p:sp>
+      <p:sp>
+        <p:nvSpPr>
+          <p:cNvPr id="6" name="TextBox 5"/>
+          <p:cNvSpPr txBox="1"/>
+          <p:nvPr/>
+        </p:nvSpPr>
+        <p:spPr>
+          <a:xfrm>
+            <a:off x="5257800" y="2148840"/>
+            <a:ext cx="6035040" cy="640080"/>
+          </a:xfrm>
+          <a:prstGeom prst="rect">
+            <a:avLst/>
+          </a:prstGeom>
+          <a:noFill/>
+        </p:spPr>
+        <p:txBody>
+          <a:bodyPr wrap="square">
+            <a:spAutoFit/>
+          </a:bodyPr>
+          <a:lstStyle/>
+          <a:p>
+            <a:pPr algn="l">
+              <a:defRPr sz="1300">
                 <a:solidFill>
                   <a:srgbClr val="FFFFFF"/>
                 </a:solidFill>
-                <a:latin typeface="Arial"/>
-              </a:rPr>
-              <a:t>Computes (Transactions / Unique Visitors) * 100 on a given day. Excludes staff trajectories automatically using metadata tags.</a:t>
-            </a:r>
-          </a:p>
-          <a:p>
-            <a:pPr>
-              <a:spcAft>
-                <a:spcPts val="2000"/>
-              </a:spcAft>
-              <a:defRPr sz="1800" b="1">
-                <a:solidFill>
-                  <a:srgbClr val="06B6D4"/>
-                </a:solidFill>
-                <a:latin typeface="Arial"/>
+                <a:latin typeface="Outfit"/>
               </a:defRPr>
             </a:pPr>
             <a:r>
-              <a:t>•  Session-Based Journey Funnel: </a:t>
-            </a:r>
-            <a:r>
-              <a:rPr sz="1600" b="0">
+              <a:t>Captures overall physical footfall entries into the store camera bounds (excluding staff).</a:t>
+            </a:r>
+          </a:p>
+        </p:txBody>
+      </p:sp>
+      <p:sp>
+        <p:nvSpPr>
+          <p:cNvPr id="7" name="Rectangle 6"/>
+          <p:cNvSpPr/>
+          <p:nvPr/>
+        </p:nvSpPr>
+        <p:spPr>
+          <a:xfrm>
+            <a:off x="731520" y="3108960"/>
+            <a:ext cx="4114800" cy="914400"/>
+          </a:xfrm>
+          <a:prstGeom prst="rect">
+            <a:avLst/>
+          </a:prstGeom>
+          <a:solidFill>
+            <a:srgbClr val="16102C"/>
+          </a:solidFill>
+          <a:ln w="31750">
+            <a:solidFill>
+              <a:srgbClr val="7E22CE"/>
+            </a:solidFill>
+          </a:ln>
+        </p:spPr>
+        <p:style>
+          <a:lnRef idx="1">
+            <a:schemeClr val="accent1"/>
+          </a:lnRef>
+          <a:fillRef idx="3">
+            <a:schemeClr val="accent1"/>
+          </a:fillRef>
+          <a:effectRef idx="2">
+            <a:schemeClr val="accent1"/>
+          </a:effectRef>
+          <a:fontRef idx="minor">
+            <a:schemeClr val="lt1"/>
+          </a:fontRef>
+        </p:style>
+        <p:txBody>
+          <a:bodyPr rtlCol="0" anchor="ctr"/>
+          <a:lstStyle/>
+          <a:p>
+            <a:pPr algn="ctr"/>
+          </a:p>
+        </p:txBody>
+      </p:sp>
+      <p:sp>
+        <p:nvSpPr>
+          <p:cNvPr id="8" name="TextBox 7"/>
+          <p:cNvSpPr txBox="1"/>
+          <p:nvPr/>
+        </p:nvSpPr>
+        <p:spPr>
+          <a:xfrm>
+            <a:off x="868680" y="3246120"/>
+            <a:ext cx="3840480" cy="640080"/>
+          </a:xfrm>
+          <a:prstGeom prst="rect">
+            <a:avLst/>
+          </a:prstGeom>
+          <a:noFill/>
+        </p:spPr>
+        <p:txBody>
+          <a:bodyPr wrap="square">
+            <a:spAutoFit/>
+          </a:bodyPr>
+          <a:lstStyle/>
+          <a:p>
+            <a:pPr algn="l">
+              <a:defRPr sz="1400" b="1">
+                <a:solidFill>
+                  <a:srgbClr val="7E22CE"/>
+                </a:solidFill>
+                <a:latin typeface="Outfit"/>
+              </a:defRPr>
+            </a:pPr>
+            <a:r>
+              <a:t>STAGE 2: PRODUCT AREA BROWSE (Zone Traffic)</a:t>
+            </a:r>
+          </a:p>
+        </p:txBody>
+      </p:sp>
+      <p:sp>
+        <p:nvSpPr>
+          <p:cNvPr id="9" name="Rectangle 8"/>
+          <p:cNvSpPr/>
+          <p:nvPr/>
+        </p:nvSpPr>
+        <p:spPr>
+          <a:xfrm>
+            <a:off x="5120640" y="3108960"/>
+            <a:ext cx="6336792" cy="914400"/>
+          </a:xfrm>
+          <a:prstGeom prst="rect">
+            <a:avLst/>
+          </a:prstGeom>
+          <a:solidFill>
+            <a:srgbClr val="16102C"/>
+          </a:solidFill>
+          <a:ln w="12700">
+            <a:solidFill>
+              <a:srgbClr val="7E22CE"/>
+            </a:solidFill>
+          </a:ln>
+        </p:spPr>
+        <p:style>
+          <a:lnRef idx="1">
+            <a:schemeClr val="accent1"/>
+          </a:lnRef>
+          <a:fillRef idx="3">
+            <a:schemeClr val="accent1"/>
+          </a:fillRef>
+          <a:effectRef idx="2">
+            <a:schemeClr val="accent1"/>
+          </a:effectRef>
+          <a:fontRef idx="minor">
+            <a:schemeClr val="lt1"/>
+          </a:fontRef>
+        </p:style>
+        <p:txBody>
+          <a:bodyPr rtlCol="0" anchor="ctr"/>
+          <a:lstStyle/>
+          <a:p>
+            <a:pPr algn="ctr"/>
+          </a:p>
+        </p:txBody>
+      </p:sp>
+      <p:sp>
+        <p:nvSpPr>
+          <p:cNvPr id="10" name="TextBox 9"/>
+          <p:cNvSpPr txBox="1"/>
+          <p:nvPr/>
+        </p:nvSpPr>
+        <p:spPr>
+          <a:xfrm>
+            <a:off x="5257800" y="3246120"/>
+            <a:ext cx="6035040" cy="640080"/>
+          </a:xfrm>
+          <a:prstGeom prst="rect">
+            <a:avLst/>
+          </a:prstGeom>
+          <a:noFill/>
+        </p:spPr>
+        <p:txBody>
+          <a:bodyPr wrap="square">
+            <a:spAutoFit/>
+          </a:bodyPr>
+          <a:lstStyle/>
+          <a:p>
+            <a:pPr algn="l">
+              <a:defRPr sz="1300">
                 <a:solidFill>
                   <a:srgbClr val="FFFFFF"/>
                 </a:solidFill>
-                <a:latin typeface="Arial"/>
-              </a:rPr>
-              <a:t>Tracks visitor transitions down the retail stages: Entry -&gt; Product Browse -&gt; Billing Queue -&gt; Checkout. Handles asynchronous events and enforces non-increasing mathematical bounds.</a:t>
-            </a:r>
-          </a:p>
-          <a:p>
-            <a:pPr>
-              <a:spcAft>
-                <a:spcPts val="2000"/>
-              </a:spcAft>
-              <a:defRPr sz="1800" b="1">
-                <a:solidFill>
-                  <a:srgbClr val="06B6D4"/>
-                </a:solidFill>
-                <a:latin typeface="Arial"/>
+                <a:latin typeface="Outfit"/>
               </a:defRPr>
             </a:pPr>
             <a:r>
-              <a:t>•  Normalized Spatial Heatmaps: </a:t>
-            </a:r>
-            <a:r>
-              <a:rPr sz="1600" b="0">
+              <a:t>Maps trajectory footprints inside specific display or shelf coordinates.</a:t>
+            </a:r>
+          </a:p>
+        </p:txBody>
+      </p:sp>
+      <p:sp>
+        <p:nvSpPr>
+          <p:cNvPr id="11" name="Rectangle 10"/>
+          <p:cNvSpPr/>
+          <p:nvPr/>
+        </p:nvSpPr>
+        <p:spPr>
+          <a:xfrm>
+            <a:off x="731520" y="4206240"/>
+            <a:ext cx="4114800" cy="914400"/>
+          </a:xfrm>
+          <a:prstGeom prst="rect">
+            <a:avLst/>
+          </a:prstGeom>
+          <a:solidFill>
+            <a:srgbClr val="16102C"/>
+          </a:solidFill>
+          <a:ln w="31750">
+            <a:solidFill>
+              <a:srgbClr val="EC4899"/>
+            </a:solidFill>
+          </a:ln>
+        </p:spPr>
+        <p:style>
+          <a:lnRef idx="1">
+            <a:schemeClr val="accent1"/>
+          </a:lnRef>
+          <a:fillRef idx="3">
+            <a:schemeClr val="accent1"/>
+          </a:fillRef>
+          <a:effectRef idx="2">
+            <a:schemeClr val="accent1"/>
+          </a:effectRef>
+          <a:fontRef idx="minor">
+            <a:schemeClr val="lt1"/>
+          </a:fontRef>
+        </p:style>
+        <p:txBody>
+          <a:bodyPr rtlCol="0" anchor="ctr"/>
+          <a:lstStyle/>
+          <a:p>
+            <a:pPr algn="ctr"/>
+          </a:p>
+        </p:txBody>
+      </p:sp>
+      <p:sp>
+        <p:nvSpPr>
+          <p:cNvPr id="12" name="TextBox 11"/>
+          <p:cNvSpPr txBox="1"/>
+          <p:nvPr/>
+        </p:nvSpPr>
+        <p:spPr>
+          <a:xfrm>
+            <a:off x="868680" y="4343400"/>
+            <a:ext cx="3840480" cy="640080"/>
+          </a:xfrm>
+          <a:prstGeom prst="rect">
+            <a:avLst/>
+          </a:prstGeom>
+          <a:noFill/>
+        </p:spPr>
+        <p:txBody>
+          <a:bodyPr wrap="square">
+            <a:spAutoFit/>
+          </a:bodyPr>
+          <a:lstStyle/>
+          <a:p>
+            <a:pPr algn="l">
+              <a:defRPr sz="1400" b="1">
+                <a:solidFill>
+                  <a:srgbClr val="EC4899"/>
+                </a:solidFill>
+                <a:latin typeface="Outfit"/>
+              </a:defRPr>
+            </a:pPr>
+            <a:r>
+              <a:t>STAGE 3: BILLING QUEUE JOIN (Wait Line)</a:t>
+            </a:r>
+          </a:p>
+        </p:txBody>
+      </p:sp>
+      <p:sp>
+        <p:nvSpPr>
+          <p:cNvPr id="13" name="Rectangle 12"/>
+          <p:cNvSpPr/>
+          <p:nvPr/>
+        </p:nvSpPr>
+        <p:spPr>
+          <a:xfrm>
+            <a:off x="5120640" y="4206240"/>
+            <a:ext cx="6336792" cy="914400"/>
+          </a:xfrm>
+          <a:prstGeom prst="rect">
+            <a:avLst/>
+          </a:prstGeom>
+          <a:solidFill>
+            <a:srgbClr val="16102C"/>
+          </a:solidFill>
+          <a:ln w="12700">
+            <a:solidFill>
+              <a:srgbClr val="7E22CE"/>
+            </a:solidFill>
+          </a:ln>
+        </p:spPr>
+        <p:style>
+          <a:lnRef idx="1">
+            <a:schemeClr val="accent1"/>
+          </a:lnRef>
+          <a:fillRef idx="3">
+            <a:schemeClr val="accent1"/>
+          </a:fillRef>
+          <a:effectRef idx="2">
+            <a:schemeClr val="accent1"/>
+          </a:effectRef>
+          <a:fontRef idx="minor">
+            <a:schemeClr val="lt1"/>
+          </a:fontRef>
+        </p:style>
+        <p:txBody>
+          <a:bodyPr rtlCol="0" anchor="ctr"/>
+          <a:lstStyle/>
+          <a:p>
+            <a:pPr algn="ctr"/>
+          </a:p>
+        </p:txBody>
+      </p:sp>
+      <p:sp>
+        <p:nvSpPr>
+          <p:cNvPr id="14" name="TextBox 13"/>
+          <p:cNvSpPr txBox="1"/>
+          <p:nvPr/>
+        </p:nvSpPr>
+        <p:spPr>
+          <a:xfrm>
+            <a:off x="5257800" y="4343400"/>
+            <a:ext cx="6035040" cy="640080"/>
+          </a:xfrm>
+          <a:prstGeom prst="rect">
+            <a:avLst/>
+          </a:prstGeom>
+          <a:noFill/>
+        </p:spPr>
+        <p:txBody>
+          <a:bodyPr wrap="square">
+            <a:spAutoFit/>
+          </a:bodyPr>
+          <a:lstStyle/>
+          <a:p>
+            <a:pPr algn="l">
+              <a:defRPr sz="1300">
                 <a:solidFill>
                   <a:srgbClr val="FFFFFF"/>
                 </a:solidFill>
-                <a:latin typeface="Arial"/>
-              </a:rPr>
-              <a:t>Aggregates physical zone traffic frequencies and average dwell times, normalizing outputs to a 0-100 score for layout evaluation.</a:t>
-            </a:r>
-          </a:p>
-          <a:p>
-            <a:pPr>
-              <a:spcAft>
-                <a:spcPts val="2000"/>
-              </a:spcAft>
-              <a:defRPr sz="1800" b="1">
-                <a:solidFill>
-                  <a:srgbClr val="06B6D4"/>
-                </a:solidFill>
-                <a:latin typeface="Arial"/>
+                <a:latin typeface="Outfit"/>
               </a:defRPr>
             </a:pPr>
             <a:r>
-              <a:t>•  Queue Wait &amp; Abandonment Monitoring: </a:t>
-            </a:r>
-            <a:r>
-              <a:rPr sz="1600" b="0">
+              <a:t>Registers visitors joining checkout queue lanes (calculating waiting queue depth).</a:t>
+            </a:r>
+          </a:p>
+        </p:txBody>
+      </p:sp>
+      <p:sp>
+        <p:nvSpPr>
+          <p:cNvPr id="15" name="Rectangle 14"/>
+          <p:cNvSpPr/>
+          <p:nvPr/>
+        </p:nvSpPr>
+        <p:spPr>
+          <a:xfrm>
+            <a:off x="731520" y="5303520"/>
+            <a:ext cx="4114800" cy="914400"/>
+          </a:xfrm>
+          <a:prstGeom prst="rect">
+            <a:avLst/>
+          </a:prstGeom>
+          <a:solidFill>
+            <a:srgbClr val="16102C"/>
+          </a:solidFill>
+          <a:ln w="31750">
+            <a:solidFill>
+              <a:srgbClr val="10B981"/>
+            </a:solidFill>
+          </a:ln>
+        </p:spPr>
+        <p:style>
+          <a:lnRef idx="1">
+            <a:schemeClr val="accent1"/>
+          </a:lnRef>
+          <a:fillRef idx="3">
+            <a:schemeClr val="accent1"/>
+          </a:fillRef>
+          <a:effectRef idx="2">
+            <a:schemeClr val="accent1"/>
+          </a:effectRef>
+          <a:fontRef idx="minor">
+            <a:schemeClr val="lt1"/>
+          </a:fontRef>
+        </p:style>
+        <p:txBody>
+          <a:bodyPr rtlCol="0" anchor="ctr"/>
+          <a:lstStyle/>
+          <a:p>
+            <a:pPr algn="ctr"/>
+          </a:p>
+        </p:txBody>
+      </p:sp>
+      <p:sp>
+        <p:nvSpPr>
+          <p:cNvPr id="16" name="TextBox 15"/>
+          <p:cNvSpPr txBox="1"/>
+          <p:nvPr/>
+        </p:nvSpPr>
+        <p:spPr>
+          <a:xfrm>
+            <a:off x="868680" y="5440680"/>
+            <a:ext cx="3840480" cy="640080"/>
+          </a:xfrm>
+          <a:prstGeom prst="rect">
+            <a:avLst/>
+          </a:prstGeom>
+          <a:noFill/>
+        </p:spPr>
+        <p:txBody>
+          <a:bodyPr wrap="square">
+            <a:spAutoFit/>
+          </a:bodyPr>
+          <a:lstStyle/>
+          <a:p>
+            <a:pPr algn="l">
+              <a:defRPr sz="1400" b="1">
+                <a:solidFill>
+                  <a:srgbClr val="10B981"/>
+                </a:solidFill>
+                <a:latin typeface="Outfit"/>
+              </a:defRPr>
+            </a:pPr>
+            <a:r>
+              <a:t>STAGE 4: CHECKOUT COMPLETE (POS Sale)</a:t>
+            </a:r>
+          </a:p>
+        </p:txBody>
+      </p:sp>
+      <p:sp>
+        <p:nvSpPr>
+          <p:cNvPr id="17" name="Rectangle 16"/>
+          <p:cNvSpPr/>
+          <p:nvPr/>
+        </p:nvSpPr>
+        <p:spPr>
+          <a:xfrm>
+            <a:off x="5120640" y="5303520"/>
+            <a:ext cx="6336792" cy="914400"/>
+          </a:xfrm>
+          <a:prstGeom prst="rect">
+            <a:avLst/>
+          </a:prstGeom>
+          <a:solidFill>
+            <a:srgbClr val="16102C"/>
+          </a:solidFill>
+          <a:ln w="12700">
+            <a:solidFill>
+              <a:srgbClr val="7E22CE"/>
+            </a:solidFill>
+          </a:ln>
+        </p:spPr>
+        <p:style>
+          <a:lnRef idx="1">
+            <a:schemeClr val="accent1"/>
+          </a:lnRef>
+          <a:fillRef idx="3">
+            <a:schemeClr val="accent1"/>
+          </a:fillRef>
+          <a:effectRef idx="2">
+            <a:schemeClr val="accent1"/>
+          </a:effectRef>
+          <a:fontRef idx="minor">
+            <a:schemeClr val="lt1"/>
+          </a:fontRef>
+        </p:style>
+        <p:txBody>
+          <a:bodyPr rtlCol="0" anchor="ctr"/>
+          <a:lstStyle/>
+          <a:p>
+            <a:pPr algn="ctr"/>
+          </a:p>
+        </p:txBody>
+      </p:sp>
+      <p:sp>
+        <p:nvSpPr>
+          <p:cNvPr id="18" name="TextBox 17"/>
+          <p:cNvSpPr txBox="1"/>
+          <p:nvPr/>
+        </p:nvSpPr>
+        <p:spPr>
+          <a:xfrm>
+            <a:off x="5257800" y="5440680"/>
+            <a:ext cx="6035040" cy="640080"/>
+          </a:xfrm>
+          <a:prstGeom prst="rect">
+            <a:avLst/>
+          </a:prstGeom>
+          <a:noFill/>
+        </p:spPr>
+        <p:txBody>
+          <a:bodyPr wrap="square">
+            <a:spAutoFit/>
+          </a:bodyPr>
+          <a:lstStyle/>
+          <a:p>
+            <a:pPr algn="l">
+              <a:defRPr sz="1300">
                 <a:solidFill>
                   <a:srgbClr val="FFFFFF"/>
                 </a:solidFill>
-                <a:latin typeface="Arial"/>
-              </a:rPr>
-              <a:t>Calculates billing queue wait times (served minus join times) and logs queue abandonments when visitors exit without checkouts.</a:t>
+                <a:latin typeface="Outfit"/>
+              </a:defRPr>
+            </a:pPr>
+            <a:r>
+              <a:t>Aligns with unique POS order transactions data to complete store conversion metrics.</a:t>
             </a:r>
           </a:p>
         </p:txBody>
@@ -3792,7 +5049,7 @@
         </p:nvSpPr>
         <p:spPr>
           <a:xfrm>
-            <a:off x="731520" y="457200"/>
+            <a:off x="731520" y="365760"/>
             <a:ext cx="10698480" cy="1097280"/>
           </a:xfrm>
           <a:prstGeom prst="rect">
@@ -3801,7 +5058,7 @@
           <a:noFill/>
         </p:spPr>
         <p:txBody>
-          <a:bodyPr wrap="square">
+          <a:bodyPr wrap="square" lIns="0" tIns="0" rIns="0" bIns="0">
             <a:spAutoFit/>
           </a:bodyPr>
           <a:lstStyle/>
@@ -3811,11 +5068,11 @@
                 <a:solidFill>
                   <a:srgbClr val="EC4899"/>
                 </a:solidFill>
-                <a:latin typeface="Arial"/>
+                <a:latin typeface="Outfit"/>
               </a:defRPr>
             </a:pPr>
             <a:r>
-              <a:t>OPERATIONAL ANOMALY &amp; DIAGNOSTIC ENGINE</a:t>
+              <a:t>OPERATIONAL DIAGNOSTICS &amp; ANOMALIES</a:t>
             </a:r>
           </a:p>
           <a:p>
@@ -3824,25 +5081,70 @@
                 <a:solidFill>
                   <a:srgbClr val="A39CB5"/>
                 </a:solidFill>
-                <a:latin typeface="Arial"/>
+                <a:latin typeface="Outfit"/>
               </a:defRPr>
             </a:pPr>
             <a:r>
-              <a:t>Observing friction and suggesting operations</a:t>
-            </a:r>
-          </a:p>
-        </p:txBody>
-      </p:sp>
-      <p:sp>
-        <p:nvSpPr>
-          <p:cNvPr id="3" name="TextBox 2"/>
+              <a:t>Real-time alerts classification and suggested manager actions</a:t>
+            </a:r>
+          </a:p>
+        </p:txBody>
+      </p:sp>
+      <p:sp>
+        <p:nvSpPr>
+          <p:cNvPr id="3" name="Rounded Rectangle 2"/>
+          <p:cNvSpPr/>
+          <p:nvPr/>
+        </p:nvSpPr>
+        <p:spPr>
+          <a:xfrm>
+            <a:off x="731520" y="1828800"/>
+            <a:ext cx="3328416" cy="3931920"/>
+          </a:xfrm>
+          <a:prstGeom prst="roundRect">
+            <a:avLst/>
+          </a:prstGeom>
+          <a:solidFill>
+            <a:srgbClr val="16102C"/>
+          </a:solidFill>
+          <a:ln w="31750">
+            <a:solidFill>
+              <a:srgbClr val="EF4444"/>
+            </a:solidFill>
+          </a:ln>
+        </p:spPr>
+        <p:style>
+          <a:lnRef idx="1">
+            <a:schemeClr val="accent1"/>
+          </a:lnRef>
+          <a:fillRef idx="3">
+            <a:schemeClr val="accent1"/>
+          </a:fillRef>
+          <a:effectRef idx="2">
+            <a:schemeClr val="accent1"/>
+          </a:effectRef>
+          <a:fontRef idx="minor">
+            <a:schemeClr val="lt1"/>
+          </a:fontRef>
+        </p:style>
+        <p:txBody>
+          <a:bodyPr rtlCol="0" anchor="ctr"/>
+          <a:lstStyle/>
+          <a:p>
+            <a:pPr algn="ctr"/>
+          </a:p>
+        </p:txBody>
+      </p:sp>
+      <p:sp>
+        <p:nvSpPr>
+          <p:cNvPr id="4" name="TextBox 3"/>
           <p:cNvSpPr txBox="1"/>
           <p:nvPr/>
         </p:nvSpPr>
         <p:spPr>
           <a:xfrm>
-            <a:off x="731520" y="1828800"/>
-            <a:ext cx="10698480" cy="4114800"/>
+            <a:off x="868680" y="2011680"/>
+            <a:ext cx="3054096" cy="3566160"/>
           </a:xfrm>
           <a:prstGeom prst="rect">
             <a:avLst/>
@@ -3857,101 +5159,350 @@
           <a:p>
             <a:pPr>
               <a:spcAft>
-                <a:spcPts val="2000"/>
+                <a:spcPts val="1500"/>
               </a:spcAft>
-              <a:defRPr sz="1800" b="1">
-                <a:solidFill>
-                  <a:srgbClr val="EC4899"/>
-                </a:solidFill>
-                <a:latin typeface="Arial"/>
+              <a:defRPr sz="1600" b="1">
+                <a:solidFill>
+                  <a:srgbClr val="EF4444"/>
+                </a:solidFill>
+                <a:latin typeface="Outfit"/>
               </a:defRPr>
             </a:pPr>
             <a:r>
-              <a:t>•  Queue Spike Alerts (Severity: WARN / CRITICAL): </a:t>
-            </a:r>
-            <a:r>
-              <a:rPr sz="1600" b="0">
+              <a:t>CRITICAL SEVERITY</a:t>
+            </a:r>
+          </a:p>
+          <a:p>
+            <a:pPr>
+              <a:defRPr sz="1400" b="1">
                 <a:solidFill>
                   <a:srgbClr val="FFFFFF"/>
                 </a:solidFill>
-                <a:latin typeface="Arial"/>
-              </a:rPr>
-              <a:t>Detects line buildups immediately. Suggests allocating cashier backup stations.</a:t>
+                <a:latin typeface="Outfit"/>
+              </a:defRPr>
+            </a:pPr>
+            <a:r>
+              <a:t>•  Conversion Drop</a:t>
             </a:r>
           </a:p>
           <a:p>
             <a:pPr>
               <a:spcAft>
-                <a:spcPts val="2000"/>
+                <a:spcPts val="1500"/>
               </a:spcAft>
-              <a:defRPr sz="1800" b="1">
-                <a:solidFill>
-                  <a:srgbClr val="EC4899"/>
-                </a:solidFill>
-                <a:latin typeface="Arial"/>
+              <a:defRPr sz="1100">
+                <a:solidFill>
+                  <a:srgbClr val="A39CB5"/>
+                </a:solidFill>
+                <a:latin typeface="Outfit"/>
               </a:defRPr>
             </a:pPr>
             <a:r>
-              <a:t>•  Conversion Drop Alerts (Severity: CRITICAL): </a:t>
-            </a:r>
-            <a:r>
-              <a:rPr sz="1600" b="0">
+              <a:t>Triggers when visitor conversion rates drop below threshold. Suggests checking checkout lanes and POS connection states.</a:t>
+            </a:r>
+          </a:p>
+          <a:p>
+            <a:pPr>
+              <a:defRPr sz="1400" b="1">
                 <a:solidFill>
                   <a:srgbClr val="FFFFFF"/>
                 </a:solidFill>
-                <a:latin typeface="Arial"/>
-              </a:rPr>
-              <a:t>Triggers when visitor conversion falls below bounds, prompting checkout checkout checks.</a:t>
-            </a:r>
-          </a:p>
+                <a:latin typeface="Outfit"/>
+              </a:defRPr>
+            </a:pPr>
+            <a:r>
+              <a:t>•  Queue Abandonment</a:t>
+            </a:r>
+          </a:p>
+          <a:p>
+            <a:pPr>
+              <a:defRPr sz="1100">
+                <a:solidFill>
+                  <a:srgbClr val="A39CB5"/>
+                </a:solidFill>
+                <a:latin typeface="Outfit"/>
+              </a:defRPr>
+            </a:pPr>
+            <a:r>
+              <a:t>Triggered when visitors exit queue lines before checkout, suggesting active cashier backup deployment.</a:t>
+            </a:r>
+          </a:p>
+        </p:txBody>
+      </p:sp>
+      <p:sp>
+        <p:nvSpPr>
+          <p:cNvPr id="5" name="Rounded Rectangle 4"/>
+          <p:cNvSpPr/>
+          <p:nvPr/>
+        </p:nvSpPr>
+        <p:spPr>
+          <a:xfrm>
+            <a:off x="4425696" y="1828800"/>
+            <a:ext cx="3328416" cy="3931920"/>
+          </a:xfrm>
+          <a:prstGeom prst="roundRect">
+            <a:avLst/>
+          </a:prstGeom>
+          <a:solidFill>
+            <a:srgbClr val="16102C"/>
+          </a:solidFill>
+          <a:ln w="31750">
+            <a:solidFill>
+              <a:srgbClr val="F97316"/>
+            </a:solidFill>
+          </a:ln>
+        </p:spPr>
+        <p:style>
+          <a:lnRef idx="1">
+            <a:schemeClr val="accent1"/>
+          </a:lnRef>
+          <a:fillRef idx="3">
+            <a:schemeClr val="accent1"/>
+          </a:fillRef>
+          <a:effectRef idx="2">
+            <a:schemeClr val="accent1"/>
+          </a:effectRef>
+          <a:fontRef idx="minor">
+            <a:schemeClr val="lt1"/>
+          </a:fontRef>
+        </p:style>
+        <p:txBody>
+          <a:bodyPr rtlCol="0" anchor="ctr"/>
+          <a:lstStyle/>
+          <a:p>
+            <a:pPr algn="ctr"/>
+          </a:p>
+        </p:txBody>
+      </p:sp>
+      <p:sp>
+        <p:nvSpPr>
+          <p:cNvPr id="6" name="TextBox 5"/>
+          <p:cNvSpPr txBox="1"/>
+          <p:nvPr/>
+        </p:nvSpPr>
+        <p:spPr>
+          <a:xfrm>
+            <a:off x="4562856" y="2011680"/>
+            <a:ext cx="3054096" cy="3566160"/>
+          </a:xfrm>
+          <a:prstGeom prst="rect">
+            <a:avLst/>
+          </a:prstGeom>
+          <a:noFill/>
+        </p:spPr>
+        <p:txBody>
+          <a:bodyPr wrap="square">
+            <a:spAutoFit/>
+          </a:bodyPr>
+          <a:lstStyle/>
           <a:p>
             <a:pPr>
               <a:spcAft>
-                <a:spcPts val="2000"/>
+                <a:spcPts val="1500"/>
               </a:spcAft>
-              <a:defRPr sz="1800" b="1">
-                <a:solidFill>
-                  <a:srgbClr val="EC4899"/>
-                </a:solidFill>
-                <a:latin typeface="Arial"/>
+              <a:defRPr sz="1600" b="1">
+                <a:solidFill>
+                  <a:srgbClr val="F97316"/>
+                </a:solidFill>
+                <a:latin typeface="Outfit"/>
               </a:defRPr>
             </a:pPr>
             <a:r>
-              <a:t>•  Dead Zone Identifications (Severity: INFO): </a:t>
-            </a:r>
-            <a:r>
-              <a:rPr sz="1600" b="0">
+              <a:t>WARNING SEVERITY</a:t>
+            </a:r>
+          </a:p>
+          <a:p>
+            <a:pPr>
+              <a:defRPr sz="1400" b="1">
                 <a:solidFill>
                   <a:srgbClr val="FFFFFF"/>
                 </a:solidFill>
-                <a:latin typeface="Arial"/>
-              </a:rPr>
-              <a:t>Flags shelves or display stands getting zero visitor dwell interaction, suggesting layout reconfiguration.</a:t>
+                <a:latin typeface="Outfit"/>
+              </a:defRPr>
+            </a:pPr>
+            <a:r>
+              <a:t>•  Queue Line Spike</a:t>
             </a:r>
           </a:p>
           <a:p>
             <a:pPr>
               <a:spcAft>
-                <a:spcPts val="2000"/>
+                <a:spcPts val="1500"/>
               </a:spcAft>
-              <a:defRPr sz="1800" b="1">
-                <a:solidFill>
-                  <a:srgbClr val="EC4899"/>
-                </a:solidFill>
-                <a:latin typeface="Arial"/>
+              <a:defRPr sz="1100">
+                <a:solidFill>
+                  <a:srgbClr val="A39CB5"/>
+                </a:solidFill>
+                <a:latin typeface="Outfit"/>
               </a:defRPr>
             </a:pPr>
             <a:r>
-              <a:t>•  Layout Bottleneck Alerts (Severity: INFO): </a:t>
-            </a:r>
-            <a:r>
-              <a:rPr sz="1600" b="0">
+              <a:t>Triggered when active queue length or wait times exceed limits. Suggests opening dynamic checkouts.</a:t>
+            </a:r>
+          </a:p>
+          <a:p>
+            <a:pPr>
+              <a:defRPr sz="1400" b="1">
                 <a:solidFill>
                   <a:srgbClr val="FFFFFF"/>
                 </a:solidFill>
-                <a:latin typeface="Arial"/>
-              </a:rPr>
-              <a:t>Identifies zones with average dwell times exceeding thresholds (e.g. 45s), highlighting congestion friction.</a:t>
+                <a:latin typeface="Outfit"/>
+              </a:defRPr>
+            </a:pPr>
+            <a:r>
+              <a:t>•  Long wait times</a:t>
+            </a:r>
+          </a:p>
+          <a:p>
+            <a:pPr>
+              <a:defRPr sz="1100">
+                <a:solidFill>
+                  <a:srgbClr val="A39CB5"/>
+                </a:solidFill>
+                <a:latin typeface="Outfit"/>
+              </a:defRPr>
+            </a:pPr>
+            <a:r>
+              <a:t>Tracks customers waiting in line for more than 15 seconds, alerting managers to direct helpers.</a:t>
+            </a:r>
+          </a:p>
+        </p:txBody>
+      </p:sp>
+      <p:sp>
+        <p:nvSpPr>
+          <p:cNvPr id="7" name="Rounded Rectangle 6"/>
+          <p:cNvSpPr/>
+          <p:nvPr/>
+        </p:nvSpPr>
+        <p:spPr>
+          <a:xfrm>
+            <a:off x="8119872" y="1828800"/>
+            <a:ext cx="3328416" cy="3931920"/>
+          </a:xfrm>
+          <a:prstGeom prst="roundRect">
+            <a:avLst/>
+          </a:prstGeom>
+          <a:solidFill>
+            <a:srgbClr val="16102C"/>
+          </a:solidFill>
+          <a:ln w="31750">
+            <a:solidFill>
+              <a:srgbClr val="06B6D4"/>
+            </a:solidFill>
+          </a:ln>
+        </p:spPr>
+        <p:style>
+          <a:lnRef idx="1">
+            <a:schemeClr val="accent1"/>
+          </a:lnRef>
+          <a:fillRef idx="3">
+            <a:schemeClr val="accent1"/>
+          </a:fillRef>
+          <a:effectRef idx="2">
+            <a:schemeClr val="accent1"/>
+          </a:effectRef>
+          <a:fontRef idx="minor">
+            <a:schemeClr val="lt1"/>
+          </a:fontRef>
+        </p:style>
+        <p:txBody>
+          <a:bodyPr rtlCol="0" anchor="ctr"/>
+          <a:lstStyle/>
+          <a:p>
+            <a:pPr algn="ctr"/>
+          </a:p>
+        </p:txBody>
+      </p:sp>
+      <p:sp>
+        <p:nvSpPr>
+          <p:cNvPr id="8" name="TextBox 7"/>
+          <p:cNvSpPr txBox="1"/>
+          <p:nvPr/>
+        </p:nvSpPr>
+        <p:spPr>
+          <a:xfrm>
+            <a:off x="8257032" y="2011680"/>
+            <a:ext cx="3054096" cy="3566160"/>
+          </a:xfrm>
+          <a:prstGeom prst="rect">
+            <a:avLst/>
+          </a:prstGeom>
+          <a:noFill/>
+        </p:spPr>
+        <p:txBody>
+          <a:bodyPr wrap="square">
+            <a:spAutoFit/>
+          </a:bodyPr>
+          <a:lstStyle/>
+          <a:p>
+            <a:pPr>
+              <a:spcAft>
+                <a:spcPts val="1500"/>
+              </a:spcAft>
+              <a:defRPr sz="1600" b="1">
+                <a:solidFill>
+                  <a:srgbClr val="06B6D4"/>
+                </a:solidFill>
+                <a:latin typeface="Outfit"/>
+              </a:defRPr>
+            </a:pPr>
+            <a:r>
+              <a:t>INFO SEVERITY</a:t>
+            </a:r>
+          </a:p>
+          <a:p>
+            <a:pPr>
+              <a:defRPr sz="1400" b="1">
+                <a:solidFill>
+                  <a:srgbClr val="FFFFFF"/>
+                </a:solidFill>
+                <a:latin typeface="Outfit"/>
+              </a:defRPr>
+            </a:pPr>
+            <a:r>
+              <a:t>•  Dead Zone Alerts</a:t>
+            </a:r>
+          </a:p>
+          <a:p>
+            <a:pPr>
+              <a:spcAft>
+                <a:spcPts val="1500"/>
+              </a:spcAft>
+              <a:defRPr sz="1100">
+                <a:solidFill>
+                  <a:srgbClr val="A39CB5"/>
+                </a:solidFill>
+                <a:latin typeface="Outfit"/>
+              </a:defRPr>
+            </a:pPr>
+            <a:r>
+              <a:t>Flags display stands or layout zones getting zero visitor interactions despite high footfalls.</a:t>
+            </a:r>
+          </a:p>
+          <a:p>
+            <a:pPr>
+              <a:defRPr sz="1400" b="1">
+                <a:solidFill>
+                  <a:srgbClr val="FFFFFF"/>
+                </a:solidFill>
+                <a:latin typeface="Outfit"/>
+              </a:defRPr>
+            </a:pPr>
+            <a:r>
+              <a:t>•  Layout Congestion</a:t>
+            </a:r>
+          </a:p>
+          <a:p>
+            <a:pPr>
+              <a:defRPr sz="1100">
+                <a:solidFill>
+                  <a:srgbClr val="A39CB5"/>
+                </a:solidFill>
+                <a:latin typeface="Outfit"/>
+              </a:defRPr>
+            </a:pPr>
+            <a:r>
+              <a:t>Identifies shelves causing traffic bottlenecks (dwell times &gt; 45s) to suggest layout widening.</a:t>
             </a:r>
           </a:p>
         </p:txBody>
@@ -3990,7 +5541,7 @@
         </p:nvSpPr>
         <p:spPr>
           <a:xfrm>
-            <a:off x="731520" y="457200"/>
+            <a:off x="731520" y="365760"/>
             <a:ext cx="10698480" cy="1097280"/>
           </a:xfrm>
           <a:prstGeom prst="rect">
@@ -3999,7 +5550,7 @@
           <a:noFill/>
         </p:spPr>
         <p:txBody>
-          <a:bodyPr wrap="square">
+          <a:bodyPr wrap="square" lIns="0" tIns="0" rIns="0" bIns="0">
             <a:spAutoFit/>
           </a:bodyPr>
           <a:lstStyle/>
@@ -4009,11 +5560,11 @@
                 <a:solidFill>
                   <a:srgbClr val="EC4899"/>
                 </a:solidFill>
-                <a:latin typeface="Arial"/>
+                <a:latin typeface="Outfit"/>
               </a:defRPr>
             </a:pPr>
             <a:r>
-              <a:t>PRODUCTION READINESS &amp; BUSINESS VALUE</a:t>
+              <a:t>PRODUCTION READINESS &amp; ARCHITECTURE CHOICES</a:t>
             </a:r>
           </a:p>
           <a:p>
@@ -4022,25 +5573,70 @@
                 <a:solidFill>
                   <a:srgbClr val="A39CB5"/>
                 </a:solidFill>
-                <a:latin typeface="Arial"/>
+                <a:latin typeface="Outfit"/>
               </a:defRPr>
             </a:pPr>
             <a:r>
-              <a:t>Zero-friction deployment, full validation</a:t>
-            </a:r>
-          </a:p>
-        </p:txBody>
-      </p:sp>
-      <p:sp>
-        <p:nvSpPr>
-          <p:cNvPr id="3" name="TextBox 2"/>
+              <a:t>Engineered for robust operations and low setup friction</a:t>
+            </a:r>
+          </a:p>
+        </p:txBody>
+      </p:sp>
+      <p:sp>
+        <p:nvSpPr>
+          <p:cNvPr id="3" name="Rounded Rectangle 2"/>
+          <p:cNvSpPr/>
+          <p:nvPr/>
+        </p:nvSpPr>
+        <p:spPr>
+          <a:xfrm>
+            <a:off x="731520" y="1828800"/>
+            <a:ext cx="5175504" cy="3931920"/>
+          </a:xfrm>
+          <a:prstGeom prst="roundRect">
+            <a:avLst/>
+          </a:prstGeom>
+          <a:solidFill>
+            <a:srgbClr val="16102C"/>
+          </a:solidFill>
+          <a:ln w="31750">
+            <a:solidFill>
+              <a:srgbClr val="06B6D4"/>
+            </a:solidFill>
+          </a:ln>
+        </p:spPr>
+        <p:style>
+          <a:lnRef idx="1">
+            <a:schemeClr val="accent1"/>
+          </a:lnRef>
+          <a:fillRef idx="3">
+            <a:schemeClr val="accent1"/>
+          </a:fillRef>
+          <a:effectRef idx="2">
+            <a:schemeClr val="accent1"/>
+          </a:effectRef>
+          <a:fontRef idx="minor">
+            <a:schemeClr val="lt1"/>
+          </a:fontRef>
+        </p:style>
+        <p:txBody>
+          <a:bodyPr rtlCol="0" anchor="ctr"/>
+          <a:lstStyle/>
+          <a:p>
+            <a:pPr algn="ctr"/>
+          </a:p>
+        </p:txBody>
+      </p:sp>
+      <p:sp>
+        <p:nvSpPr>
+          <p:cNvPr id="4" name="TextBox 3"/>
           <p:cNvSpPr txBox="1"/>
           <p:nvPr/>
         </p:nvSpPr>
         <p:spPr>
           <a:xfrm>
-            <a:off x="731520" y="1828800"/>
-            <a:ext cx="10698480" cy="4114800"/>
+            <a:off x="914400" y="2011680"/>
+            <a:ext cx="4809744" cy="3566160"/>
           </a:xfrm>
           <a:prstGeom prst="rect">
             <a:avLst/>
@@ -4055,101 +5651,251 @@
           <a:p>
             <a:pPr>
               <a:spcAft>
-                <a:spcPts val="2000"/>
+                <a:spcPts val="1500"/>
               </a:spcAft>
               <a:defRPr sz="1800" b="1">
                 <a:solidFill>
                   <a:srgbClr val="06B6D4"/>
                 </a:solidFill>
-                <a:latin typeface="Arial"/>
+                <a:latin typeface="Outfit"/>
               </a:defRPr>
             </a:pPr>
             <a:r>
-              <a:t>•  Docker Compose Orchestration: </a:t>
-            </a:r>
-            <a:r>
-              <a:rPr sz="1600" b="0">
-                <a:solidFill>
-                  <a:srgbClr val="FFFFFF"/>
-                </a:solidFill>
-                <a:latin typeface="Arial"/>
-              </a:rPr>
-              <a:t>Deploys with zero manual configuration. Automatically initializes SQLite database schema and bootstraps sample event records.</a:t>
+              <a:t>OBSERVABILITY &amp; INTEGRATION</a:t>
             </a:r>
           </a:p>
           <a:p>
             <a:pPr>
               <a:spcAft>
-                <a:spcPts val="2000"/>
+                <a:spcPts val="1000"/>
+              </a:spcAft>
+              <a:defRPr sz="1300" b="1">
+                <a:solidFill>
+                  <a:srgbClr val="FFFFFF"/>
+                </a:solidFill>
+                <a:latin typeface="Outfit"/>
+              </a:defRPr>
+            </a:pPr>
+            <a:r>
+              <a:t>•  Structured JSON Logging: </a:t>
+            </a:r>
+            <a:r>
+              <a:rPr sz="1100" b="0">
+                <a:solidFill>
+                  <a:srgbClr val="A39CB5"/>
+                </a:solidFill>
+                <a:latin typeface="Outfit"/>
+              </a:rPr>
+              <a:t>HTTP requests trace telemetry (trace_id, store_id, latency_ms) printed cleanly in stdout for collector pipes (e.g. FluentBit).</a:t>
+            </a:r>
+          </a:p>
+          <a:p>
+            <a:pPr>
+              <a:spcAft>
+                <a:spcPts val="1000"/>
+              </a:spcAft>
+              <a:defRPr sz="1300" b="1">
+                <a:solidFill>
+                  <a:srgbClr val="FFFFFF"/>
+                </a:solidFill>
+                <a:latin typeface="Outfit"/>
+              </a:defRPr>
+            </a:pPr>
+            <a:r>
+              <a:t>•  Graceful DB Degradation: </a:t>
+            </a:r>
+            <a:r>
+              <a:rPr sz="1100" b="0">
+                <a:solidFill>
+                  <a:srgbClr val="A39CB5"/>
+                </a:solidFill>
+                <a:latin typeface="Outfit"/>
+              </a:rPr>
+              <a:t>Intercepts SQLiteOperationalErrors during write locks to cleanly return HTTP 503 rather than breaking server runtime.</a:t>
+            </a:r>
+          </a:p>
+          <a:p>
+            <a:pPr>
+              <a:spcAft>
+                <a:spcPts val="1000"/>
+              </a:spcAft>
+              <a:defRPr sz="1300" b="1">
+                <a:solidFill>
+                  <a:srgbClr val="FFFFFF"/>
+                </a:solidFill>
+                <a:latin typeface="Outfit"/>
+              </a:defRPr>
+            </a:pPr>
+            <a:r>
+              <a:t>•  Stack Trace Suppression: </a:t>
+            </a:r>
+            <a:r>
+              <a:rPr sz="1100" b="0">
+                <a:solidFill>
+                  <a:srgbClr val="A39CB5"/>
+                </a:solidFill>
+                <a:latin typeface="Outfit"/>
+              </a:rPr>
+              <a:t>Global catch-all exception middleware catches unhandled python runtime exceptions to mask raw tracebacks from public clients.</a:t>
+            </a:r>
+          </a:p>
+        </p:txBody>
+      </p:sp>
+      <p:sp>
+        <p:nvSpPr>
+          <p:cNvPr id="5" name="Rounded Rectangle 4"/>
+          <p:cNvSpPr/>
+          <p:nvPr/>
+        </p:nvSpPr>
+        <p:spPr>
+          <a:xfrm>
+            <a:off x="6272784" y="1828800"/>
+            <a:ext cx="5175504" cy="3931920"/>
+          </a:xfrm>
+          <a:prstGeom prst="roundRect">
+            <a:avLst/>
+          </a:prstGeom>
+          <a:solidFill>
+            <a:srgbClr val="16102C"/>
+          </a:solidFill>
+          <a:ln w="31750">
+            <a:solidFill>
+              <a:srgbClr val="EC4899"/>
+            </a:solidFill>
+          </a:ln>
+        </p:spPr>
+        <p:style>
+          <a:lnRef idx="1">
+            <a:schemeClr val="accent1"/>
+          </a:lnRef>
+          <a:fillRef idx="3">
+            <a:schemeClr val="accent1"/>
+          </a:fillRef>
+          <a:effectRef idx="2">
+            <a:schemeClr val="accent1"/>
+          </a:effectRef>
+          <a:fontRef idx="minor">
+            <a:schemeClr val="lt1"/>
+          </a:fontRef>
+        </p:style>
+        <p:txBody>
+          <a:bodyPr rtlCol="0" anchor="ctr"/>
+          <a:lstStyle/>
+          <a:p>
+            <a:pPr algn="ctr"/>
+          </a:p>
+        </p:txBody>
+      </p:sp>
+      <p:sp>
+        <p:nvSpPr>
+          <p:cNvPr id="6" name="TextBox 5"/>
+          <p:cNvSpPr txBox="1"/>
+          <p:nvPr/>
+        </p:nvSpPr>
+        <p:spPr>
+          <a:xfrm>
+            <a:off x="6455664" y="2011680"/>
+            <a:ext cx="4809744" cy="3566160"/>
+          </a:xfrm>
+          <a:prstGeom prst="rect">
+            <a:avLst/>
+          </a:prstGeom>
+          <a:noFill/>
+        </p:spPr>
+        <p:txBody>
+          <a:bodyPr wrap="square">
+            <a:spAutoFit/>
+          </a:bodyPr>
+          <a:lstStyle/>
+          <a:p>
+            <a:pPr>
+              <a:spcAft>
+                <a:spcPts val="1500"/>
               </a:spcAft>
               <a:defRPr sz="1800" b="1">
                 <a:solidFill>
-                  <a:srgbClr val="06B6D4"/>
-                </a:solidFill>
-                <a:latin typeface="Arial"/>
+                  <a:srgbClr val="EC4899"/>
+                </a:solidFill>
+                <a:latin typeface="Outfit"/>
               </a:defRPr>
             </a:pPr>
             <a:r>
-              <a:t>•  Structured Observability &amp; JSON Logs: </a:t>
-            </a:r>
-            <a:r>
-              <a:rPr sz="1600" b="0">
-                <a:solidFill>
-                  <a:srgbClr val="FFFFFF"/>
-                </a:solidFill>
-                <a:latin typeface="Arial"/>
-              </a:rPr>
-              <a:t>Requests trace IDs, database locks mapping to HTTP 503, and global unhandled exception filters to hide stack traces.</a:t>
+              <a:t>VALIDATION &amp; DEPLOYMENT</a:t>
             </a:r>
           </a:p>
           <a:p>
             <a:pPr>
               <a:spcAft>
-                <a:spcPts val="2000"/>
+                <a:spcPts val="1000"/>
               </a:spcAft>
-              <a:defRPr sz="1800" b="1">
-                <a:solidFill>
-                  <a:srgbClr val="06B6D4"/>
-                </a:solidFill>
-                <a:latin typeface="Arial"/>
+              <a:defRPr sz="1300" b="1">
+                <a:solidFill>
+                  <a:srgbClr val="FFFFFF"/>
+                </a:solidFill>
+                <a:latin typeface="Outfit"/>
               </a:defRPr>
             </a:pPr>
             <a:r>
-              <a:t>•  14/14 Pytest Test Suites: </a:t>
-            </a:r>
-            <a:r>
-              <a:rPr sz="1600" b="0">
-                <a:solidFill>
-                  <a:srgbClr val="FFFFFF"/>
-                </a:solidFill>
-                <a:latin typeface="Arial"/>
+              <a:t>•  Docker Compose Works: </a:t>
+            </a:r>
+            <a:r>
+              <a:rPr sz="1100" b="0">
+                <a:solidFill>
+                  <a:srgbClr val="A39CB5"/>
+                </a:solidFill>
+                <a:latin typeface="Outfit"/>
               </a:rPr>
-              <a:t>Validated against empty store, all-staff clips, zero purchases, and re-entry funnel deduplications with robust thread-safe Windows lock bypassing.</a:t>
+              <a:t>Builds containers in single command. Automatically mounts local volumes and handles database seed imports.</a:t>
             </a:r>
           </a:p>
           <a:p>
             <a:pPr>
               <a:spcAft>
-                <a:spcPts val="2000"/>
+                <a:spcPts val="1000"/>
               </a:spcAft>
-              <a:defRPr sz="1800" b="1">
-                <a:solidFill>
-                  <a:srgbClr val="06B6D4"/>
-                </a:solidFill>
-                <a:latin typeface="Arial"/>
+              <a:defRPr sz="1300" b="1">
+                <a:solidFill>
+                  <a:srgbClr val="FFFFFF"/>
+                </a:solidFill>
+                <a:latin typeface="Outfit"/>
               </a:defRPr>
             </a:pPr>
             <a:r>
-              <a:t>•  Business Impact: </a:t>
-            </a:r>
-            <a:r>
-              <a:rPr sz="1600" b="0">
+              <a:t>•  14/14 Pytest Test Coverage: </a:t>
+            </a:r>
+            <a:r>
+              <a:rPr sz="1100" b="0">
+                <a:solidFill>
+                  <a:srgbClr val="A39CB5"/>
+                </a:solidFill>
+                <a:latin typeface="Outfit"/>
+              </a:rPr>
+              <a:t>Validates special compliance test scenarios (Empty Store, All-Staff Clips, Zero Purchases, Re-entry Funnels).</a:t>
+            </a:r>
+          </a:p>
+          <a:p>
+            <a:pPr>
+              <a:spcAft>
+                <a:spcPts val="1000"/>
+              </a:spcAft>
+              <a:defRPr sz="1300" b="1">
                 <a:solidFill>
                   <a:srgbClr val="FFFFFF"/>
                 </a:solidFill>
-                <a:latin typeface="Arial"/>
+                <a:latin typeface="Outfit"/>
+              </a:defRPr>
+            </a:pPr>
+            <a:r>
+              <a:t>•  Portability &amp; Portings: </a:t>
+            </a:r>
+            <a:r>
+              <a:rPr sz="1100" b="0">
+                <a:solidFill>
+                  <a:srgbClr val="A39CB5"/>
+                </a:solidFill>
+                <a:latin typeface="Outfit"/>
               </a:rPr>
-              <a:t>Empowers retail brands to make data-driven layout updates, optimize staff scheduling, minimize queue drop-offs, and increase sales conversion rates.</a:t>
+              <a:t>Custom Centroid/IoU tracking replaces C++ libraries (DeepSORT/ByteTrack), running out-of-the-box on CPU without compilers.</a:t>
             </a:r>
           </a:p>
         </p:txBody>

</xml_diff>